<commit_message>
Raise Python baseline to 3.10
</commit_message>
<xml_diff>
--- a/samples/cn_art.pptx
+++ b/samples/cn_art.pptx
@@ -8,9 +8,11 @@
     <p:sldId id="256" r:id="rId7"/>
     <p:sldId id="257" r:id="rId8"/>
     <p:sldId id="258" r:id="rId9"/>
-    <p:sldId id="259" r:id="rId11"/>
-    <p:sldId id="260" r:id="rId12"/>
-    <p:sldId id="261" r:id="rId13"/>
+    <p:sldId id="259" r:id="rId10"/>
+    <p:sldId id="260" r:id="rId11"/>
+    <p:sldId id="261" r:id="rId12"/>
+    <p:sldId id="262" r:id="rId13"/>
+    <p:sldId id="263" r:id="rId14"/>
   </p:sldIdLst>
   <p:sldSz cx="9144000" cy="6858000" type="screen4x3"/>
   <p:notesSz cx="6858000" cy="9144000"/>
@@ -110,496 +112,6 @@
     </a:lvl9pPr>
   </p:defaultTextStyle>
 </p:presentation>
-</file>
-
-<file path=ppt/notesMasters/notesMaster1.xml><?xml version="1.0" encoding="utf-8"?>
-<p:notesMaster xmlns:a="http://schemas.openxmlformats.org/drawingml/2006/main" xmlns:p="http://schemas.openxmlformats.org/presentationml/2006/main" xmlns:r="http://schemas.openxmlformats.org/officeDocument/2006/relationships">
-  <p:cSld>
-    <p:bg>
-      <p:bgRef idx="1001">
-        <a:schemeClr val="bg1"/>
-      </p:bgRef>
-    </p:bg>
-    <p:spTree>
-      <p:nvGrpSpPr>
-        <p:cNvPr id="1" name=""/>
-        <p:cNvGrpSpPr/>
-        <p:nvPr/>
-      </p:nvGrpSpPr>
-      <p:grpSpPr>
-        <a:xfrm>
-          <a:off x="0" y="0"/>
-          <a:ext cx="0" cy="0"/>
-          <a:chOff x="0" y="0"/>
-          <a:chExt cx="0" cy="0"/>
-        </a:xfrm>
-      </p:grpSpPr>
-      <p:sp>
-        <p:nvSpPr>
-          <p:cNvPr id="2" name="Header Placeholder 1"/>
-          <p:cNvSpPr>
-            <a:spLocks noGrp="1"/>
-          </p:cNvSpPr>
-          <p:nvPr>
-            <p:ph type="hdr" sz="quarter"/>
-          </p:nvPr>
-        </p:nvSpPr>
-        <p:spPr>
-          <a:xfrm>
-            <a:off x="0" y="0"/>
-            <a:ext cx="2971800" cy="457200"/>
-          </a:xfrm>
-          <a:prstGeom prst="rect">
-            <a:avLst/>
-          </a:prstGeom>
-        </p:spPr>
-        <p:txBody>
-          <a:bodyPr vert="horz" lIns="91440" tIns="45720" rIns="91440" bIns="45720" rtlCol="0"/>
-          <a:lstStyle>
-            <a:lvl1pPr algn="l">
-              <a:defRPr sz="1200"/>
-            </a:lvl1pPr>
-          </a:lstStyle>
-          <a:p>
-            <a:endParaRPr lang="en-US"/>
-          </a:p>
-        </p:txBody>
-      </p:sp>
-      <p:sp>
-        <p:nvSpPr>
-          <p:cNvPr id="3" name="Date Placeholder 2"/>
-          <p:cNvSpPr>
-            <a:spLocks noGrp="1"/>
-          </p:cNvSpPr>
-          <p:nvPr>
-            <p:ph type="dt" idx="1"/>
-          </p:nvPr>
-        </p:nvSpPr>
-        <p:spPr>
-          <a:xfrm>
-            <a:off x="3884613" y="0"/>
-            <a:ext cx="2971800" cy="457200"/>
-          </a:xfrm>
-          <a:prstGeom prst="rect">
-            <a:avLst/>
-          </a:prstGeom>
-        </p:spPr>
-        <p:txBody>
-          <a:bodyPr vert="horz" lIns="91440" tIns="45720" rIns="91440" bIns="45720" rtlCol="0"/>
-          <a:lstStyle>
-            <a:lvl1pPr algn="r">
-              <a:defRPr sz="1200"/>
-            </a:lvl1pPr>
-          </a:lstStyle>
-          <a:p>
-            <a:fld id="{0F89C1C7-3DCD-1040-A9CF-14679D8B5DDD}" type="datetimeFigureOut">
-              <a:rPr lang="en-US" smtClean="0"/>
-              <a:t>10/17/16</a:t>
-            </a:fld>
-            <a:endParaRPr lang="en-US"/>
-          </a:p>
-        </p:txBody>
-      </p:sp>
-      <p:sp>
-        <p:nvSpPr>
-          <p:cNvPr id="4" name="Slide Image Placeholder 3"/>
-          <p:cNvSpPr>
-            <a:spLocks noGrp="1" noRot="1" noChangeAspect="1"/>
-          </p:cNvSpPr>
-          <p:nvPr>
-            <p:ph type="sldImg" idx="2"/>
-          </p:nvPr>
-        </p:nvSpPr>
-        <p:spPr>
-          <a:xfrm>
-            <a:off x="1143000" y="685800"/>
-            <a:ext cx="4572000" cy="3429000"/>
-          </a:xfrm>
-          <a:prstGeom prst="rect">
-            <a:avLst/>
-          </a:prstGeom>
-          <a:noFill/>
-          <a:ln w="12700">
-            <a:solidFill>
-              <a:prstClr val="black"/>
-            </a:solidFill>
-          </a:ln>
-        </p:spPr>
-        <p:txBody>
-          <a:bodyPr vert="horz" lIns="91440" tIns="45720" rIns="91440" bIns="45720" rtlCol="0" anchor="ctr"/>
-          <a:lstStyle/>
-          <a:p>
-            <a:endParaRPr lang="en-US"/>
-          </a:p>
-        </p:txBody>
-      </p:sp>
-      <p:sp>
-        <p:nvSpPr>
-          <p:cNvPr id="5" name="Notes Placeholder 4"/>
-          <p:cNvSpPr>
-            <a:spLocks noGrp="1"/>
-          </p:cNvSpPr>
-          <p:nvPr>
-            <p:ph type="body" sz="quarter" idx="3"/>
-          </p:nvPr>
-        </p:nvSpPr>
-        <p:spPr>
-          <a:xfrm>
-            <a:off x="685800" y="4343400"/>
-            <a:ext cx="5486400" cy="4114800"/>
-          </a:xfrm>
-          <a:prstGeom prst="rect">
-            <a:avLst/>
-          </a:prstGeom>
-        </p:spPr>
-        <p:txBody>
-          <a:bodyPr vert="horz" lIns="91440" tIns="45720" rIns="91440" bIns="45720" rtlCol="0"/>
-          <a:lstStyle/>
-          <a:p>
-            <a:pPr lvl="0"/>
-            <a:r>
-              <a:rPr lang="en-US" smtClean="0"/>
-              <a:t>Click to edit Master text styles</a:t>
-            </a:r>
-          </a:p>
-          <a:p>
-            <a:pPr lvl="1"/>
-            <a:r>
-              <a:rPr lang="en-US" smtClean="0"/>
-              <a:t>Second level</a:t>
-            </a:r>
-          </a:p>
-          <a:p>
-            <a:pPr lvl="2"/>
-            <a:r>
-              <a:rPr lang="en-US" smtClean="0"/>
-              <a:t>Third level</a:t>
-            </a:r>
-          </a:p>
-          <a:p>
-            <a:pPr lvl="3"/>
-            <a:r>
-              <a:rPr lang="en-US" smtClean="0"/>
-              <a:t>Fourth level</a:t>
-            </a:r>
-          </a:p>
-          <a:p>
-            <a:pPr lvl="4"/>
-            <a:r>
-              <a:rPr lang="en-US" smtClean="0"/>
-              <a:t>Fifth level</a:t>
-            </a:r>
-            <a:endParaRPr lang="en-US"/>
-          </a:p>
-        </p:txBody>
-      </p:sp>
-      <p:sp>
-        <p:nvSpPr>
-          <p:cNvPr id="6" name="Footer Placeholder 5"/>
-          <p:cNvSpPr>
-            <a:spLocks noGrp="1"/>
-          </p:cNvSpPr>
-          <p:nvPr>
-            <p:ph type="ftr" sz="quarter" idx="4"/>
-          </p:nvPr>
-        </p:nvSpPr>
-        <p:spPr>
-          <a:xfrm>
-            <a:off x="0" y="8685213"/>
-            <a:ext cx="2971800" cy="457200"/>
-          </a:xfrm>
-          <a:prstGeom prst="rect">
-            <a:avLst/>
-          </a:prstGeom>
-        </p:spPr>
-        <p:txBody>
-          <a:bodyPr vert="horz" lIns="91440" tIns="45720" rIns="91440" bIns="45720" rtlCol="0" anchor="b"/>
-          <a:lstStyle>
-            <a:lvl1pPr algn="l">
-              <a:defRPr sz="1200"/>
-            </a:lvl1pPr>
-          </a:lstStyle>
-          <a:p>
-            <a:endParaRPr lang="en-US"/>
-          </a:p>
-        </p:txBody>
-      </p:sp>
-      <p:sp>
-        <p:nvSpPr>
-          <p:cNvPr id="7" name="Slide Number Placeholder 6"/>
-          <p:cNvSpPr>
-            <a:spLocks noGrp="1"/>
-          </p:cNvSpPr>
-          <p:nvPr>
-            <p:ph type="sldNum" sz="quarter" idx="5"/>
-          </p:nvPr>
-        </p:nvSpPr>
-        <p:spPr>
-          <a:xfrm>
-            <a:off x="3884613" y="8685213"/>
-            <a:ext cx="2971800" cy="457200"/>
-          </a:xfrm>
-          <a:prstGeom prst="rect">
-            <a:avLst/>
-          </a:prstGeom>
-        </p:spPr>
-        <p:txBody>
-          <a:bodyPr vert="horz" lIns="91440" tIns="45720" rIns="91440" bIns="45720" rtlCol="0" anchor="b"/>
-          <a:lstStyle>
-            <a:lvl1pPr algn="r">
-              <a:defRPr sz="1200"/>
-            </a:lvl1pPr>
-          </a:lstStyle>
-          <a:p>
-            <a:fld id="{BB5E49A5-4136-284D-997B-48E1D791AD67}" type="slidenum">
-              <a:rPr lang="en-US" smtClean="0"/>
-              <a:t>‹#›</a:t>
-            </a:fld>
-            <a:endParaRPr lang="en-US"/>
-          </a:p>
-        </p:txBody>
-      </p:sp>
-    </p:spTree>
-    <p:extLst>
-      <p:ext uri="{BB962C8B-B14F-4D97-AF65-F5344CB8AC3E}">
-        <p14:creationId xmlns:p14="http://schemas.microsoft.com/office/powerpoint/2010/main" val="2623252185"/>
-      </p:ext>
-    </p:extLst>
-  </p:cSld>
-  <p:clrMap bg1="lt1" tx1="dk1" bg2="lt2" tx2="dk2" accent1="accent1" accent2="accent2" accent3="accent3" accent4="accent4" accent5="accent5" accent6="accent6" hlink="hlink" folHlink="folHlink"/>
-  <p:notesStyle>
-    <a:lvl1pPr marL="0" algn="l" defTabSz="457200" rtl="0" eaLnBrk="1" latinLnBrk="0" hangingPunct="1">
-      <a:defRPr sz="1200" kern="1200">
-        <a:solidFill>
-          <a:schemeClr val="tx1"/>
-        </a:solidFill>
-        <a:latin typeface="+mn-lt"/>
-        <a:ea typeface="+mn-ea"/>
-        <a:cs typeface="+mn-cs"/>
-      </a:defRPr>
-    </a:lvl1pPr>
-    <a:lvl2pPr marL="457200" algn="l" defTabSz="457200" rtl="0" eaLnBrk="1" latinLnBrk="0" hangingPunct="1">
-      <a:defRPr sz="1200" kern="1200">
-        <a:solidFill>
-          <a:schemeClr val="tx1"/>
-        </a:solidFill>
-        <a:latin typeface="+mn-lt"/>
-        <a:ea typeface="+mn-ea"/>
-        <a:cs typeface="+mn-cs"/>
-      </a:defRPr>
-    </a:lvl2pPr>
-    <a:lvl3pPr marL="914400" algn="l" defTabSz="457200" rtl="0" eaLnBrk="1" latinLnBrk="0" hangingPunct="1">
-      <a:defRPr sz="1200" kern="1200">
-        <a:solidFill>
-          <a:schemeClr val="tx1"/>
-        </a:solidFill>
-        <a:latin typeface="+mn-lt"/>
-        <a:ea typeface="+mn-ea"/>
-        <a:cs typeface="+mn-cs"/>
-      </a:defRPr>
-    </a:lvl3pPr>
-    <a:lvl4pPr marL="1371600" algn="l" defTabSz="457200" rtl="0" eaLnBrk="1" latinLnBrk="0" hangingPunct="1">
-      <a:defRPr sz="1200" kern="1200">
-        <a:solidFill>
-          <a:schemeClr val="tx1"/>
-        </a:solidFill>
-        <a:latin typeface="+mn-lt"/>
-        <a:ea typeface="+mn-ea"/>
-        <a:cs typeface="+mn-cs"/>
-      </a:defRPr>
-    </a:lvl4pPr>
-    <a:lvl5pPr marL="1828800" algn="l" defTabSz="457200" rtl="0" eaLnBrk="1" latinLnBrk="0" hangingPunct="1">
-      <a:defRPr sz="1200" kern="1200">
-        <a:solidFill>
-          <a:schemeClr val="tx1"/>
-        </a:solidFill>
-        <a:latin typeface="+mn-lt"/>
-        <a:ea typeface="+mn-ea"/>
-        <a:cs typeface="+mn-cs"/>
-      </a:defRPr>
-    </a:lvl5pPr>
-    <a:lvl6pPr marL="2286000" algn="l" defTabSz="457200" rtl="0" eaLnBrk="1" latinLnBrk="0" hangingPunct="1">
-      <a:defRPr sz="1200" kern="1200">
-        <a:solidFill>
-          <a:schemeClr val="tx1"/>
-        </a:solidFill>
-        <a:latin typeface="+mn-lt"/>
-        <a:ea typeface="+mn-ea"/>
-        <a:cs typeface="+mn-cs"/>
-      </a:defRPr>
-    </a:lvl6pPr>
-    <a:lvl7pPr marL="2743200" algn="l" defTabSz="457200" rtl="0" eaLnBrk="1" latinLnBrk="0" hangingPunct="1">
-      <a:defRPr sz="1200" kern="1200">
-        <a:solidFill>
-          <a:schemeClr val="tx1"/>
-        </a:solidFill>
-        <a:latin typeface="+mn-lt"/>
-        <a:ea typeface="+mn-ea"/>
-        <a:cs typeface="+mn-cs"/>
-      </a:defRPr>
-    </a:lvl7pPr>
-    <a:lvl8pPr marL="3200400" algn="l" defTabSz="457200" rtl="0" eaLnBrk="1" latinLnBrk="0" hangingPunct="1">
-      <a:defRPr sz="1200" kern="1200">
-        <a:solidFill>
-          <a:schemeClr val="tx1"/>
-        </a:solidFill>
-        <a:latin typeface="+mn-lt"/>
-        <a:ea typeface="+mn-ea"/>
-        <a:cs typeface="+mn-cs"/>
-      </a:defRPr>
-    </a:lvl8pPr>
-    <a:lvl9pPr marL="3657600" algn="l" defTabSz="457200" rtl="0" eaLnBrk="1" latinLnBrk="0" hangingPunct="1">
-      <a:defRPr sz="1200" kern="1200">
-        <a:solidFill>
-          <a:schemeClr val="tx1"/>
-        </a:solidFill>
-        <a:latin typeface="+mn-lt"/>
-        <a:ea typeface="+mn-ea"/>
-        <a:cs typeface="+mn-cs"/>
-      </a:defRPr>
-    </a:lvl9pPr>
-  </p:notesStyle>
-</p:notesMaster>
-</file>
-
-<file path=ppt/notesSlides/notesSlide1.xml><?xml version="1.0" encoding="utf-8"?>
-<p:notes xmlns:a="http://schemas.openxmlformats.org/drawingml/2006/main" xmlns:p="http://schemas.openxmlformats.org/presentationml/2006/main" xmlns:r="http://schemas.openxmlformats.org/officeDocument/2006/relationships">
-  <p:cSld>
-    <p:spTree>
-      <p:nvGrpSpPr>
-        <p:cNvPr id="1" name=""/>
-        <p:cNvGrpSpPr/>
-        <p:nvPr/>
-      </p:nvGrpSpPr>
-      <p:grpSpPr>
-        <a:xfrm>
-          <a:off x="0" y="0"/>
-          <a:ext cx="0" cy="0"/>
-          <a:chOff x="0" y="0"/>
-          <a:chExt cx="0" cy="0"/>
-        </a:xfrm>
-      </p:grpSpPr>
-      <p:sp>
-        <p:nvSpPr>
-          <p:cNvPr id="2" name="Slide Image Placeholder 1"/>
-          <p:cNvSpPr>
-            <a:spLocks noGrp="1"/>
-          </p:cNvSpPr>
-          <p:nvPr>
-            <p:ph type="sldImg" idx="2"/>
-          </p:nvPr>
-        </p:nvSpPr>
-        <p:spPr/>
-      </p:sp>
-      <p:sp>
-        <p:nvSpPr>
-          <p:cNvPr id="3" name="Notes Placeholder 2"/>
-          <p:cNvSpPr>
-            <a:spLocks noGrp="1"/>
-          </p:cNvSpPr>
-          <p:nvPr>
-            <p:ph type="body" idx="3" sz="quarter"/>
-          </p:nvPr>
-        </p:nvSpPr>
-        <p:spPr/>
-        <p:txBody>
-          <a:bodyPr/>
-          <a:lstStyle/>
-          <a:p>
-            <a:r>
-              <a:t>本节重点讲解文艺复兴如何利用数学工具彻底改变了人类观察图像的方式。</a:t>
-            </a:r>
-          </a:p>
-        </p:txBody>
-      </p:sp>
-      <p:sp>
-        <p:nvSpPr>
-          <p:cNvPr id="4" name="Slide Number Placeholder 3"/>
-          <p:cNvSpPr>
-            <a:spLocks noGrp="1"/>
-          </p:cNvSpPr>
-          <p:nvPr>
-            <p:ph type="sldNum" idx="5" sz="quarter"/>
-          </p:nvPr>
-        </p:nvSpPr>
-        <p:spPr/>
-      </p:sp>
-    </p:spTree>
-  </p:cSld>
-  <p:clrMapOvr>
-    <a:masterClrMapping/>
-  </p:clrMapOvr>
-</p:notes>
-</file>
-
-<file path=ppt/notesSlides/notesSlide2.xml><?xml version="1.0" encoding="utf-8"?>
-<p:notes xmlns:a="http://schemas.openxmlformats.org/drawingml/2006/main" xmlns:p="http://schemas.openxmlformats.org/presentationml/2006/main" xmlns:r="http://schemas.openxmlformats.org/officeDocument/2006/relationships">
-  <p:cSld>
-    <p:spTree>
-      <p:nvGrpSpPr>
-        <p:cNvPr id="1" name=""/>
-        <p:cNvGrpSpPr/>
-        <p:nvPr/>
-      </p:nvGrpSpPr>
-      <p:grpSpPr>
-        <a:xfrm>
-          <a:off x="0" y="0"/>
-          <a:ext cx="0" cy="0"/>
-          <a:chOff x="0" y="0"/>
-          <a:chExt cx="0" cy="0"/>
-        </a:xfrm>
-      </p:grpSpPr>
-      <p:sp>
-        <p:nvSpPr>
-          <p:cNvPr id="2" name="Slide Image Placeholder 1"/>
-          <p:cNvSpPr>
-            <a:spLocks noGrp="1"/>
-          </p:cNvSpPr>
-          <p:nvPr>
-            <p:ph type="sldImg" idx="2"/>
-          </p:nvPr>
-        </p:nvSpPr>
-        <p:spPr/>
-      </p:sp>
-      <p:sp>
-        <p:nvSpPr>
-          <p:cNvPr id="3" name="Notes Placeholder 2"/>
-          <p:cNvSpPr>
-            <a:spLocks noGrp="1"/>
-          </p:cNvSpPr>
-          <p:nvPr>
-            <p:ph type="body" idx="3" sz="quarter"/>
-          </p:nvPr>
-        </p:nvSpPr>
-        <p:spPr/>
-        <p:txBody>
-          <a:bodyPr/>
-          <a:lstStyle/>
-          <a:p>
-            <a:r>
-              <a:t>分析达芬奇如何通过精妙的光学观察超越了机械的透视法，赋予肖像画以生命感。</a:t>
-            </a:r>
-          </a:p>
-        </p:txBody>
-      </p:sp>
-      <p:sp>
-        <p:nvSpPr>
-          <p:cNvPr id="4" name="Slide Number Placeholder 3"/>
-          <p:cNvSpPr>
-            <a:spLocks noGrp="1"/>
-          </p:cNvSpPr>
-          <p:nvPr>
-            <p:ph type="sldNum" idx="5" sz="quarter"/>
-          </p:nvPr>
-        </p:nvSpPr>
-        <p:spPr/>
-      </p:sp>
-    </p:spTree>
-  </p:cSld>
-  <p:clrMapOvr>
-    <a:masterClrMapping/>
-  </p:clrMapOvr>
-</p:notes>
 </file>
 
 <file path=ppt/slideLayouts/slideLayout1.xml><?xml version="1.0" encoding="utf-8"?>
@@ -3578,9 +3090,17 @@
   <p:cSld>
     <p:bg>
       <p:bgPr>
-        <a:solidFill>
-          <a:srgbClr val="FFFAF0"/>
-        </a:solidFill>
+        <a:gradFill rotWithShape="1">
+          <a:gsLst>
+            <a:gs pos="0">
+              <a:srgbClr val="19161C"/>
+            </a:gs>
+            <a:gs pos="100000">
+              <a:srgbClr val="362A3A"/>
+            </a:gs>
+          </a:gsLst>
+          <a:lin scaled="0" ang="5400000"/>
+        </a:gradFill>
         <a:effectLst/>
       </p:bgPr>
     </p:bg>
@@ -3593,54 +3113,276 @@
       <p:grpSpPr/>
       <p:sp>
         <p:nvSpPr>
-          <p:cNvPr id="2" name="Title 1"/>
-          <p:cNvSpPr>
-            <a:spLocks noGrp="1"/>
-          </p:cNvSpPr>
-          <p:nvPr>
-            <p:ph type="ctrTitle"/>
-          </p:nvPr>
-        </p:nvSpPr>
-        <p:spPr/>
-        <p:txBody>
-          <a:bodyPr/>
-          <a:lstStyle/>
-          <a:p>
-            <a:r>
-              <a:rPr>
-                <a:solidFill>
-                  <a:srgbClr val="C83296"/>
-                </a:solidFill>
-                <a:latin typeface="Verdana"/>
-              </a:rPr>
-              <a:t>透视与光影：文艺复兴艺术的技术巅峰</a:t>
-            </a:r>
-          </a:p>
-        </p:txBody>
-      </p:sp>
-      <p:sp>
-        <p:nvSpPr>
-          <p:cNvPr id="3" name="Subtitle 2"/>
-          <p:cNvSpPr>
-            <a:spLocks noGrp="1"/>
-          </p:cNvSpPr>
-          <p:nvPr>
-            <p:ph type="subTitle" idx="1"/>
-          </p:nvPr>
-        </p:nvSpPr>
-        <p:spPr/>
-        <p:txBody>
-          <a:bodyPr/>
-          <a:lstStyle/>
-          <a:p>
-            <a:r>
-              <a:rPr>
-                <a:solidFill>
-                  <a:srgbClr val="3C283C"/>
-                </a:solidFill>
-                <a:latin typeface="Verdana"/>
-              </a:rPr>
-              <a:t>Topic: 文艺复兴大师与技法深度赏析</a:t>
+          <p:cNvPr id="2" name="TextBox 1"/>
+          <p:cNvSpPr txBox="1"/>
+          <p:nvPr/>
+        </p:nvSpPr>
+        <p:spPr>
+          <a:xfrm>
+            <a:off x="640080" y="411480"/>
+            <a:ext cx="7498079" cy="292608"/>
+          </a:xfrm>
+          <a:prstGeom prst="rect">
+            <a:avLst/>
+          </a:prstGeom>
+          <a:noFill/>
+        </p:spPr>
+        <p:txBody>
+          <a:bodyPr wrap="square" lIns="237744" rIns="237744" tIns="237744" bIns="237744">
+            <a:spAutoFit/>
+          </a:bodyPr>
+          <a:lstStyle/>
+          <a:p>
+            <a:pPr>
+              <a:spcAft>
+                <a:spcPts val="144"/>
+              </a:spcAft>
+              <a:defRPr sz="1200" b="1" i="0">
+                <a:solidFill>
+                  <a:srgbClr val="CC9C48"/>
+                </a:solidFill>
+                <a:latin typeface="Aptos"/>
+              </a:defRPr>
+            </a:pPr>
+            <a:r>
+              <a:t>AUTOPPT</a:t>
+            </a:r>
+          </a:p>
+        </p:txBody>
+      </p:sp>
+      <p:sp>
+        <p:nvSpPr>
+          <p:cNvPr id="3" name="TextBox 2"/>
+          <p:cNvSpPr txBox="1"/>
+          <p:nvPr/>
+        </p:nvSpPr>
+        <p:spPr>
+          <a:xfrm>
+            <a:off x="640080" y="722376"/>
+            <a:ext cx="7498079" cy="1645920"/>
+          </a:xfrm>
+          <a:prstGeom prst="rect">
+            <a:avLst/>
+          </a:prstGeom>
+          <a:noFill/>
+        </p:spPr>
+        <p:txBody>
+          <a:bodyPr wrap="square" lIns="237744" rIns="237744" tIns="237744" bIns="237744">
+            <a:spAutoFit/>
+          </a:bodyPr>
+          <a:lstStyle/>
+          <a:p>
+            <a:pPr>
+              <a:spcAft>
+                <a:spcPts val="230"/>
+              </a:spcAft>
+              <a:defRPr sz="4600" b="1" i="0">
+                <a:solidFill>
+                  <a:srgbClr val="E2BF5A"/>
+                </a:solidFill>
+                <a:latin typeface="Georgia"/>
+              </a:defRPr>
+            </a:pPr>
+            <a:r>
+              <a:t>文艺复兴艺术</a:t>
+            </a:r>
+          </a:p>
+        </p:txBody>
+      </p:sp>
+      <p:sp>
+        <p:nvSpPr>
+          <p:cNvPr id="4" name="TextBox 3"/>
+          <p:cNvSpPr txBox="1"/>
+          <p:nvPr/>
+        </p:nvSpPr>
+        <p:spPr>
+          <a:xfrm>
+            <a:off x="640080" y="1673351"/>
+            <a:ext cx="7498079" cy="822960"/>
+          </a:xfrm>
+          <a:prstGeom prst="rect">
+            <a:avLst/>
+          </a:prstGeom>
+          <a:noFill/>
+        </p:spPr>
+        <p:txBody>
+          <a:bodyPr wrap="square" lIns="237744" rIns="237744" tIns="237744" bIns="237744">
+            <a:spAutoFit/>
+          </a:bodyPr>
+          <a:lstStyle/>
+          <a:p>
+            <a:pPr>
+              <a:spcAft>
+                <a:spcPts val="216"/>
+              </a:spcAft>
+              <a:defRPr sz="1800" b="0" i="0">
+                <a:solidFill>
+                  <a:srgbClr val="C5BCA9"/>
+                </a:solidFill>
+                <a:latin typeface="Georgia"/>
+              </a:defRPr>
+            </a:pPr>
+            <a:r>
+              <a:t>一场关于空间、身体与权力的视觉重写</a:t>
+            </a:r>
+          </a:p>
+        </p:txBody>
+      </p:sp>
+      <p:sp>
+        <p:nvSpPr>
+          <p:cNvPr id="5" name="Rectangle 4"/>
+          <p:cNvSpPr/>
+          <p:nvPr/>
+        </p:nvSpPr>
+        <p:spPr>
+          <a:xfrm>
+            <a:off x="640080" y="1508760"/>
+            <a:ext cx="1371600" cy="45720"/>
+          </a:xfrm>
+          <a:prstGeom prst="rect">
+            <a:avLst/>
+          </a:prstGeom>
+          <a:solidFill>
+            <a:srgbClr val="CC9C48"/>
+          </a:solidFill>
+          <a:ln>
+            <a:noFill/>
+          </a:ln>
+        </p:spPr>
+        <p:style>
+          <a:lnRef idx="1">
+            <a:schemeClr val="accent1"/>
+          </a:lnRef>
+          <a:fillRef idx="3">
+            <a:schemeClr val="accent1"/>
+          </a:fillRef>
+          <a:effectRef idx="2">
+            <a:schemeClr val="accent1"/>
+          </a:effectRef>
+          <a:fontRef idx="minor">
+            <a:schemeClr val="lt1"/>
+          </a:fontRef>
+        </p:style>
+        <p:txBody>
+          <a:bodyPr rtlCol="0" anchor="ctr"/>
+          <a:lstStyle/>
+          <a:p>
+            <a:pPr algn="ctr"/>
+          </a:p>
+        </p:txBody>
+      </p:sp>
+      <p:sp>
+        <p:nvSpPr>
+          <p:cNvPr id="6" name="Rounded Rectangle 5"/>
+          <p:cNvSpPr/>
+          <p:nvPr/>
+        </p:nvSpPr>
+        <p:spPr>
+          <a:xfrm>
+            <a:off x="640080" y="2194560"/>
+            <a:ext cx="3840480" cy="1325880"/>
+          </a:xfrm>
+          <a:prstGeom prst="roundRect">
+            <a:avLst/>
+          </a:prstGeom>
+          <a:solidFill>
+            <a:srgbClr val="262028"/>
+          </a:solidFill>
+          <a:ln w="15875">
+            <a:solidFill>
+              <a:srgbClr val="6F5A37"/>
+            </a:solidFill>
+          </a:ln>
+        </p:spPr>
+        <p:style>
+          <a:lnRef idx="1">
+            <a:schemeClr val="accent1"/>
+          </a:lnRef>
+          <a:fillRef idx="3">
+            <a:schemeClr val="accent1"/>
+          </a:fillRef>
+          <a:effectRef idx="2">
+            <a:schemeClr val="accent1"/>
+          </a:effectRef>
+          <a:fontRef idx="minor">
+            <a:schemeClr val="lt1"/>
+          </a:fontRef>
+        </p:style>
+        <p:txBody>
+          <a:bodyPr rtlCol="0" anchor="ctr"/>
+          <a:lstStyle/>
+          <a:p>
+            <a:pPr algn="ctr"/>
+          </a:p>
+        </p:txBody>
+      </p:sp>
+      <p:sp>
+        <p:nvSpPr>
+          <p:cNvPr id="7" name="TextBox 6"/>
+          <p:cNvSpPr txBox="1"/>
+          <p:nvPr/>
+        </p:nvSpPr>
+        <p:spPr>
+          <a:xfrm>
+            <a:off x="731519" y="2267712"/>
+            <a:ext cx="3657600" cy="1179576"/>
+          </a:xfrm>
+          <a:prstGeom prst="rect">
+            <a:avLst/>
+          </a:prstGeom>
+          <a:noFill/>
+        </p:spPr>
+        <p:txBody>
+          <a:bodyPr wrap="square" lIns="237744" rIns="237744" tIns="237744" bIns="237744">
+            <a:spAutoFit/>
+          </a:bodyPr>
+          <a:lstStyle/>
+          <a:p>
+            <a:pPr>
+              <a:spcAft>
+                <a:spcPts val="144"/>
+              </a:spcAft>
+              <a:defRPr sz="1800" b="0" i="0">
+                <a:solidFill>
+                  <a:srgbClr val="EAE8E2"/>
+                </a:solidFill>
+                <a:latin typeface="Georgia"/>
+              </a:defRPr>
+            </a:pPr>
+            <a:r>
+              <a:t>PowerPoint-native output</a:t>
+            </a:r>
+          </a:p>
+          <a:p>
+            <a:pPr>
+              <a:spcAft>
+                <a:spcPts val="144"/>
+              </a:spcAft>
+              <a:defRPr sz="1800" b="0" i="0">
+                <a:solidFill>
+                  <a:srgbClr val="EAE8E2"/>
+                </a:solidFill>
+                <a:latin typeface="Georgia"/>
+              </a:defRPr>
+            </a:pPr>
+            <a:r>
+              <a:t>Layout-aware slide planning</a:t>
+            </a:r>
+          </a:p>
+          <a:p>
+            <a:pPr>
+              <a:spcAft>
+                <a:spcPts val="144"/>
+              </a:spcAft>
+              <a:defRPr sz="1800" b="0" i="0">
+                <a:solidFill>
+                  <a:srgbClr val="EAE8E2"/>
+                </a:solidFill>
+                <a:latin typeface="Georgia"/>
+              </a:defRPr>
+            </a:pPr>
+            <a:r>
+              <a:t>Template and remix ready</a:t>
             </a:r>
           </a:p>
         </p:txBody>
@@ -3658,9 +3400,17 @@
   <p:cSld>
     <p:bg>
       <p:bgPr>
-        <a:solidFill>
-          <a:srgbClr val="FFFAF0"/>
-        </a:solidFill>
+        <a:gradFill rotWithShape="1">
+          <a:gsLst>
+            <a:gs pos="0">
+              <a:srgbClr val="19161C"/>
+            </a:gs>
+            <a:gs pos="100000">
+              <a:srgbClr val="362A3A"/>
+            </a:gs>
+          </a:gsLst>
+          <a:lin scaled="0" ang="5400000"/>
+        </a:gradFill>
         <a:effectLst/>
       </p:bgPr>
     </p:bg>
@@ -3671,48 +3421,149 @@
         <p:nvPr/>
       </p:nvGrpSpPr>
       <p:grpSpPr/>
-      <p:sp>
-        <p:nvSpPr>
-          <p:cNvPr id="2" name="Title 1"/>
-          <p:cNvSpPr>
-            <a:spLocks noGrp="1"/>
-          </p:cNvSpPr>
-          <p:nvPr>
-            <p:ph type="title"/>
-          </p:nvPr>
-        </p:nvSpPr>
-        <p:spPr/>
-        <p:txBody>
-          <a:bodyPr/>
-          <a:lstStyle/>
-          <a:p>
-            <a:r>
-              <a:rPr>
-                <a:solidFill>
-                  <a:srgbClr val="C83296"/>
-                </a:solidFill>
-                <a:latin typeface="Verdana"/>
-              </a:rPr>
-              <a:t>科学写实主义的黄金时代</a:t>
-            </a:r>
-          </a:p>
-        </p:txBody>
-      </p:sp>
-      <p:sp>
-        <p:nvSpPr>
-          <p:cNvPr id="3" name="Text Placeholder 2"/>
-          <p:cNvSpPr>
-            <a:spLocks noGrp="1"/>
-          </p:cNvSpPr>
-          <p:nvPr>
-            <p:ph type="body" idx="1"/>
-          </p:nvPr>
-        </p:nvSpPr>
-        <p:spPr/>
-        <p:txBody>
-          <a:bodyPr/>
-          <a:lstStyle/>
-          <a:p/>
+      <p:pic>
+        <p:nvPicPr>
+          <p:cNvPr id="2" name="Picture 1" descr="tmp0om53aay.png"/>
+          <p:cNvPicPr>
+            <a:picLocks noChangeAspect="1"/>
+          </p:cNvPicPr>
+          <p:nvPr/>
+        </p:nvPicPr>
+        <p:blipFill>
+          <a:blip r:embed="rId2"/>
+          <a:stretch>
+            <a:fillRect/>
+          </a:stretch>
+        </p:blipFill>
+        <p:spPr>
+          <a:xfrm>
+            <a:off x="0" y="0"/>
+            <a:ext cx="9144000" cy="6858000"/>
+          </a:xfrm>
+          <a:prstGeom prst="rect">
+            <a:avLst/>
+          </a:prstGeom>
+        </p:spPr>
+      </p:pic>
+      <p:sp>
+        <p:nvSpPr>
+          <p:cNvPr id="3" name="Rectangle 2"/>
+          <p:cNvSpPr/>
+          <p:nvPr/>
+        </p:nvSpPr>
+        <p:spPr>
+          <a:xfrm>
+            <a:off x="0" y="0"/>
+            <a:ext cx="9144000" cy="6858000"/>
+          </a:xfrm>
+          <a:prstGeom prst="rect">
+            <a:avLst/>
+          </a:prstGeom>
+          <a:solidFill>
+            <a:srgbClr val="080C12"/>
+          </a:solidFill>
+          <a:ln>
+            <a:noFill/>
+          </a:ln>
+        </p:spPr>
+        <p:style>
+          <a:lnRef idx="1">
+            <a:schemeClr val="accent1"/>
+          </a:lnRef>
+          <a:fillRef idx="3">
+            <a:schemeClr val="accent1"/>
+          </a:fillRef>
+          <a:effectRef idx="2">
+            <a:schemeClr val="accent1"/>
+          </a:effectRef>
+          <a:fontRef idx="minor">
+            <a:schemeClr val="lt1"/>
+          </a:fontRef>
+        </p:style>
+        <p:txBody>
+          <a:bodyPr rtlCol="0" anchor="ctr"/>
+          <a:lstStyle/>
+          <a:p>
+            <a:pPr algn="ctr"/>
+          </a:p>
+        </p:txBody>
+      </p:sp>
+      <p:sp>
+        <p:nvSpPr>
+          <p:cNvPr id="4" name="TextBox 3"/>
+          <p:cNvSpPr txBox="1"/>
+          <p:nvPr/>
+        </p:nvSpPr>
+        <p:spPr>
+          <a:xfrm>
+            <a:off x="640080" y="4389120"/>
+            <a:ext cx="7863840" cy="1097280"/>
+          </a:xfrm>
+          <a:prstGeom prst="rect">
+            <a:avLst/>
+          </a:prstGeom>
+          <a:noFill/>
+        </p:spPr>
+        <p:txBody>
+          <a:bodyPr wrap="square" lIns="237744" rIns="237744" tIns="237744" bIns="237744">
+            <a:spAutoFit/>
+          </a:bodyPr>
+          <a:lstStyle/>
+          <a:p>
+            <a:pPr>
+              <a:spcAft>
+                <a:spcPts val="552"/>
+              </a:spcAft>
+              <a:defRPr sz="4600" b="1" i="0">
+                <a:solidFill>
+                  <a:srgbClr val="FFFFFF"/>
+                </a:solidFill>
+                <a:latin typeface="Georgia"/>
+              </a:defRPr>
+            </a:pPr>
+            <a:r>
+              <a:t>展陈式开场页</a:t>
+            </a:r>
+          </a:p>
+        </p:txBody>
+      </p:sp>
+      <p:sp>
+        <p:nvSpPr>
+          <p:cNvPr id="5" name="TextBox 4"/>
+          <p:cNvSpPr txBox="1"/>
+          <p:nvPr/>
+        </p:nvSpPr>
+        <p:spPr>
+          <a:xfrm>
+            <a:off x="640080" y="6144768"/>
+            <a:ext cx="7863840" cy="274320"/>
+          </a:xfrm>
+          <a:prstGeom prst="rect">
+            <a:avLst/>
+          </a:prstGeom>
+          <a:noFill/>
+        </p:spPr>
+        <p:txBody>
+          <a:bodyPr wrap="square" lIns="237744" rIns="237744" tIns="237744" bIns="237744">
+            <a:spAutoFit/>
+          </a:bodyPr>
+          <a:lstStyle/>
+          <a:p>
+            <a:pPr>
+              <a:spcAft>
+                <a:spcPts val="144"/>
+              </a:spcAft>
+              <a:defRPr sz="1200" b="0" i="0">
+                <a:solidFill>
+                  <a:srgbClr val="F4F7FA"/>
+                </a:solidFill>
+                <a:latin typeface="Georgia"/>
+              </a:defRPr>
+            </a:pPr>
+            <a:r>
+              <a:t>更适合艺术与文化主题的海报感开场</a:t>
+            </a:r>
+          </a:p>
         </p:txBody>
       </p:sp>
     </p:spTree>
@@ -3728,9 +3579,17 @@
   <p:cSld>
     <p:bg>
       <p:bgPr>
-        <a:solidFill>
-          <a:srgbClr val="FFFAF0"/>
-        </a:solidFill>
+        <a:gradFill rotWithShape="1">
+          <a:gsLst>
+            <a:gs pos="0">
+              <a:srgbClr val="19161C"/>
+            </a:gs>
+            <a:gs pos="100000">
+              <a:srgbClr val="362A3A"/>
+            </a:gs>
+          </a:gsLst>
+          <a:lin scaled="0" ang="5400000"/>
+        </a:gradFill>
         <a:effectLst/>
       </p:bgPr>
     </p:bg>
@@ -3743,92 +3602,162 @@
       <p:grpSpPr/>
       <p:sp>
         <p:nvSpPr>
-          <p:cNvPr id="2" name="Title 1"/>
-          <p:cNvSpPr>
-            <a:spLocks noGrp="1"/>
-          </p:cNvSpPr>
-          <p:nvPr>
-            <p:ph type="title"/>
-          </p:nvPr>
-        </p:nvSpPr>
-        <p:spPr/>
-        <p:txBody>
-          <a:bodyPr/>
-          <a:lstStyle/>
-          <a:p>
-            <a:r>
-              <a:rPr>
-                <a:solidFill>
-                  <a:srgbClr val="C83296"/>
-                </a:solidFill>
-                <a:latin typeface="Verdana"/>
-              </a:rPr>
-              <a:t>数学视角的引入：线性透视法</a:t>
-            </a:r>
-          </a:p>
-        </p:txBody>
-      </p:sp>
-      <p:sp>
-        <p:nvSpPr>
-          <p:cNvPr id="3" name="Content Placeholder 2"/>
-          <p:cNvSpPr>
-            <a:spLocks noGrp="1"/>
-          </p:cNvSpPr>
-          <p:nvPr>
-            <p:ph idx="1"/>
-          </p:nvPr>
-        </p:nvSpPr>
-        <p:spPr/>
-        <p:txBody>
-          <a:bodyPr wrap="square"/>
-          <a:lstStyle/>
-          <a:p/>
-          <a:p>
-            <a:pPr/>
-            <a:r>
-              <a:rPr>
-                <a:solidFill>
-                  <a:srgbClr val="3C283C"/>
-                </a:solidFill>
-                <a:latin typeface="Verdana"/>
-              </a:rPr>
-              <a:t>布鲁内莱斯基的发现：通过数学消失点 (Vanishing Point) 在二维平面还原三维物理空间。</a:t>
-            </a:r>
-          </a:p>
-          <a:p>
-            <a:pPr/>
-            <a:r>
-              <a:rPr>
-                <a:solidFill>
-                  <a:srgbClr val="3C283C"/>
-                </a:solidFill>
-                <a:latin typeface="Verdana"/>
-              </a:rPr>
-              <a:t>马萨乔的《圣三一》：西方艺术史上第一张严格遵循线性透视规则的大型湿壁画。</a:t>
-            </a:r>
-          </a:p>
-          <a:p>
-            <a:pPr/>
-            <a:r>
-              <a:rPr>
-                <a:solidFill>
-                  <a:srgbClr val="3C283C"/>
-                </a:solidFill>
-                <a:latin typeface="Verdana"/>
-              </a:rPr>
-              <a:t>缩短透视法 (Foreshortening)：使人体部位垂直于画平面，产生强烈的立体压缩感。</a:t>
-            </a:r>
-          </a:p>
-          <a:p>
-            <a:pPr/>
-            <a:r>
-              <a:rPr>
-                <a:solidFill>
-                  <a:srgbClr val="3C283C"/>
-                </a:solidFill>
-                <a:latin typeface="Verdana"/>
-              </a:rPr>
-              <a:t>艺术与科学的深度融合：艺术家由单纯的工匠转变为具备解剖学与光学知识的知识分子。</a:t>
+          <p:cNvPr id="2" name="Rounded Rectangle 1"/>
+          <p:cNvSpPr/>
+          <p:nvPr/>
+        </p:nvSpPr>
+        <p:spPr>
+          <a:xfrm>
+            <a:off x="914400" y="1097280"/>
+            <a:ext cx="7315200" cy="4389120"/>
+          </a:xfrm>
+          <a:prstGeom prst="roundRect">
+            <a:avLst/>
+          </a:prstGeom>
+          <a:solidFill>
+            <a:srgbClr val="262028"/>
+          </a:solidFill>
+          <a:ln w="15875">
+            <a:solidFill>
+              <a:srgbClr val="6F5A37"/>
+            </a:solidFill>
+          </a:ln>
+        </p:spPr>
+        <p:style>
+          <a:lnRef idx="1">
+            <a:schemeClr val="accent1"/>
+          </a:lnRef>
+          <a:fillRef idx="3">
+            <a:schemeClr val="accent1"/>
+          </a:fillRef>
+          <a:effectRef idx="2">
+            <a:schemeClr val="accent1"/>
+          </a:effectRef>
+          <a:fontRef idx="minor">
+            <a:schemeClr val="lt1"/>
+          </a:fontRef>
+        </p:style>
+        <p:txBody>
+          <a:bodyPr rtlCol="0" anchor="ctr"/>
+          <a:lstStyle/>
+          <a:p>
+            <a:pPr algn="ctr"/>
+          </a:p>
+        </p:txBody>
+      </p:sp>
+      <p:sp>
+        <p:nvSpPr>
+          <p:cNvPr id="3" name="TextBox 2"/>
+          <p:cNvSpPr txBox="1"/>
+          <p:nvPr/>
+        </p:nvSpPr>
+        <p:spPr>
+          <a:xfrm>
+            <a:off x="1143000" y="1325880"/>
+            <a:ext cx="914400" cy="914400"/>
+          </a:xfrm>
+          <a:prstGeom prst="rect">
+            <a:avLst/>
+          </a:prstGeom>
+          <a:noFill/>
+        </p:spPr>
+        <p:txBody>
+          <a:bodyPr wrap="square" lIns="237744" rIns="237744" tIns="237744" bIns="237744">
+            <a:spAutoFit/>
+          </a:bodyPr>
+          <a:lstStyle/>
+          <a:p>
+            <a:pPr>
+              <a:spcAft>
+                <a:spcPts val="1104"/>
+              </a:spcAft>
+              <a:defRPr sz="9200" b="1" i="0">
+                <a:solidFill>
+                  <a:srgbClr val="CC9C48"/>
+                </a:solidFill>
+                <a:latin typeface="Georgia"/>
+              </a:defRPr>
+            </a:pPr>
+            <a:r>
+              <a:t>“</a:t>
+            </a:r>
+          </a:p>
+        </p:txBody>
+      </p:sp>
+      <p:sp>
+        <p:nvSpPr>
+          <p:cNvPr id="4" name="TextBox 3"/>
+          <p:cNvSpPr txBox="1"/>
+          <p:nvPr/>
+        </p:nvSpPr>
+        <p:spPr>
+          <a:xfrm>
+            <a:off x="1828800" y="1828800"/>
+            <a:ext cx="6309360" cy="2286000"/>
+          </a:xfrm>
+          <a:prstGeom prst="rect">
+            <a:avLst/>
+          </a:prstGeom>
+          <a:noFill/>
+        </p:spPr>
+        <p:txBody>
+          <a:bodyPr wrap="square" lIns="237744" rIns="237744" tIns="237744" bIns="237744">
+            <a:spAutoFit/>
+          </a:bodyPr>
+          <a:lstStyle/>
+          <a:p>
+            <a:pPr>
+              <a:spcAft>
+                <a:spcPts val="156"/>
+              </a:spcAft>
+              <a:defRPr sz="2600" b="0" i="1">
+                <a:solidFill>
+                  <a:srgbClr val="E2BF5A"/>
+                </a:solidFill>
+                <a:latin typeface="Georgia"/>
+              </a:defRPr>
+            </a:pPr>
+            <a:r>
+              <a:t>透视法不只是绘画技巧，而是一种组织世界的新方式。</a:t>
+            </a:r>
+          </a:p>
+        </p:txBody>
+      </p:sp>
+      <p:sp>
+        <p:nvSpPr>
+          <p:cNvPr id="5" name="TextBox 4"/>
+          <p:cNvSpPr txBox="1"/>
+          <p:nvPr/>
+        </p:nvSpPr>
+        <p:spPr>
+          <a:xfrm>
+            <a:off x="1828800" y="4572000"/>
+            <a:ext cx="6309360" cy="457200"/>
+          </a:xfrm>
+          <a:prstGeom prst="rect">
+            <a:avLst/>
+          </a:prstGeom>
+          <a:noFill/>
+        </p:spPr>
+        <p:txBody>
+          <a:bodyPr wrap="square" lIns="237744" rIns="237744" tIns="237744" bIns="237744">
+            <a:spAutoFit/>
+          </a:bodyPr>
+          <a:lstStyle/>
+          <a:p>
+            <a:pPr>
+              <a:spcAft>
+                <a:spcPts val="216"/>
+              </a:spcAft>
+              <a:defRPr sz="1800" b="0" i="0">
+                <a:solidFill>
+                  <a:srgbClr val="C5BCA9"/>
+                </a:solidFill>
+                <a:latin typeface="Georgia"/>
+              </a:defRPr>
+            </a:pPr>
+            <a:r>
+              <a:t>— AutoPPT Sample Desk, Art History Notes</a:t>
             </a:r>
           </a:p>
         </p:txBody>
@@ -3846,9 +3775,17 @@
   <p:cSld>
     <p:bg>
       <p:bgPr>
-        <a:solidFill>
-          <a:srgbClr val="FFFAF0"/>
-        </a:solidFill>
+        <a:gradFill rotWithShape="1">
+          <a:gsLst>
+            <a:gs pos="0">
+              <a:srgbClr val="19161C"/>
+            </a:gs>
+            <a:gs pos="100000">
+              <a:srgbClr val="362A3A"/>
+            </a:gs>
+          </a:gsLst>
+          <a:lin scaled="0" ang="5400000"/>
+        </a:gradFill>
         <a:effectLst/>
       </p:bgPr>
     </p:bg>
@@ -3861,48 +3798,271 @@
       <p:grpSpPr/>
       <p:sp>
         <p:nvSpPr>
-          <p:cNvPr id="2" name="Title 1"/>
-          <p:cNvSpPr>
-            <a:spLocks noGrp="1"/>
-          </p:cNvSpPr>
-          <p:nvPr>
-            <p:ph type="title"/>
-          </p:nvPr>
-        </p:nvSpPr>
-        <p:spPr/>
-        <p:txBody>
-          <a:bodyPr/>
-          <a:lstStyle/>
-          <a:p>
-            <a:r>
-              <a:rPr>
-                <a:solidFill>
-                  <a:srgbClr val="C83296"/>
-                </a:solidFill>
-                <a:latin typeface="Verdana"/>
-              </a:rPr>
-              <a:t>达芬奇与威尼斯画派的色彩革命</a:t>
-            </a:r>
-          </a:p>
-        </p:txBody>
-      </p:sp>
-      <p:sp>
-        <p:nvSpPr>
-          <p:cNvPr id="3" name="Text Placeholder 2"/>
-          <p:cNvSpPr>
-            <a:spLocks noGrp="1"/>
-          </p:cNvSpPr>
-          <p:nvPr>
-            <p:ph type="body" idx="1"/>
-          </p:nvPr>
-        </p:nvSpPr>
-        <p:spPr/>
-        <p:txBody>
-          <a:bodyPr/>
-          <a:lstStyle/>
-          <a:p/>
-        </p:txBody>
-      </p:sp>
+          <p:cNvPr id="2" name="TextBox 1"/>
+          <p:cNvSpPr txBox="1"/>
+          <p:nvPr/>
+        </p:nvSpPr>
+        <p:spPr>
+          <a:xfrm>
+            <a:off x="640080" y="411480"/>
+            <a:ext cx="7498079" cy="1645920"/>
+          </a:xfrm>
+          <a:prstGeom prst="rect">
+            <a:avLst/>
+          </a:prstGeom>
+          <a:noFill/>
+        </p:spPr>
+        <p:txBody>
+          <a:bodyPr wrap="square" lIns="237744" rIns="237744" tIns="237744" bIns="237744">
+            <a:spAutoFit/>
+          </a:bodyPr>
+          <a:lstStyle/>
+          <a:p>
+            <a:pPr>
+              <a:spcAft>
+                <a:spcPts val="140"/>
+              </a:spcAft>
+              <a:defRPr sz="2800" b="1" i="0">
+                <a:solidFill>
+                  <a:srgbClr val="E2BF5A"/>
+                </a:solidFill>
+                <a:latin typeface="Georgia"/>
+              </a:defRPr>
+            </a:pPr>
+            <a:r>
+              <a:t>为什么它今天仍然现代</a:t>
+            </a:r>
+          </a:p>
+        </p:txBody>
+      </p:sp>
+      <p:sp>
+        <p:nvSpPr>
+          <p:cNvPr id="3" name="Rectangle 2"/>
+          <p:cNvSpPr/>
+          <p:nvPr/>
+        </p:nvSpPr>
+        <p:spPr>
+          <a:xfrm>
+            <a:off x="640080" y="1197863"/>
+            <a:ext cx="1371600" cy="45720"/>
+          </a:xfrm>
+          <a:prstGeom prst="rect">
+            <a:avLst/>
+          </a:prstGeom>
+          <a:solidFill>
+            <a:srgbClr val="CC9C48"/>
+          </a:solidFill>
+          <a:ln>
+            <a:noFill/>
+          </a:ln>
+        </p:spPr>
+        <p:style>
+          <a:lnRef idx="1">
+            <a:schemeClr val="accent1"/>
+          </a:lnRef>
+          <a:fillRef idx="3">
+            <a:schemeClr val="accent1"/>
+          </a:fillRef>
+          <a:effectRef idx="2">
+            <a:schemeClr val="accent1"/>
+          </a:effectRef>
+          <a:fontRef idx="minor">
+            <a:schemeClr val="lt1"/>
+          </a:fontRef>
+        </p:style>
+        <p:txBody>
+          <a:bodyPr rtlCol="0" anchor="ctr"/>
+          <a:lstStyle/>
+          <a:p>
+            <a:pPr algn="ctr"/>
+          </a:p>
+        </p:txBody>
+      </p:sp>
+      <p:sp>
+        <p:nvSpPr>
+          <p:cNvPr id="4" name="Rounded Rectangle 3"/>
+          <p:cNvSpPr/>
+          <p:nvPr/>
+        </p:nvSpPr>
+        <p:spPr>
+          <a:xfrm>
+            <a:off x="658368" y="1280160"/>
+            <a:ext cx="4315967" cy="5029200"/>
+          </a:xfrm>
+          <a:prstGeom prst="roundRect">
+            <a:avLst/>
+          </a:prstGeom>
+          <a:solidFill>
+            <a:srgbClr val="262028"/>
+          </a:solidFill>
+          <a:ln w="15875">
+            <a:solidFill>
+              <a:srgbClr val="6F5A37"/>
+            </a:solidFill>
+          </a:ln>
+        </p:spPr>
+        <p:style>
+          <a:lnRef idx="1">
+            <a:schemeClr val="accent1"/>
+          </a:lnRef>
+          <a:fillRef idx="3">
+            <a:schemeClr val="accent1"/>
+          </a:fillRef>
+          <a:effectRef idx="2">
+            <a:schemeClr val="accent1"/>
+          </a:effectRef>
+          <a:fontRef idx="minor">
+            <a:schemeClr val="lt1"/>
+          </a:fontRef>
+        </p:style>
+        <p:txBody>
+          <a:bodyPr rtlCol="0" anchor="ctr"/>
+          <a:lstStyle/>
+          <a:p>
+            <a:pPr algn="ctr"/>
+          </a:p>
+        </p:txBody>
+      </p:sp>
+      <p:sp>
+        <p:nvSpPr>
+          <p:cNvPr id="5" name="Rounded Rectangle 4"/>
+          <p:cNvSpPr/>
+          <p:nvPr/>
+        </p:nvSpPr>
+        <p:spPr>
+          <a:xfrm>
+            <a:off x="5285231" y="1280160"/>
+            <a:ext cx="3200400" cy="5029200"/>
+          </a:xfrm>
+          <a:prstGeom prst="roundRect">
+            <a:avLst/>
+          </a:prstGeom>
+          <a:solidFill>
+            <a:srgbClr val="262028"/>
+          </a:solidFill>
+          <a:ln w="15875">
+            <a:solidFill>
+              <a:srgbClr val="6F5A37"/>
+            </a:solidFill>
+          </a:ln>
+        </p:spPr>
+        <p:style>
+          <a:lnRef idx="1">
+            <a:schemeClr val="accent1"/>
+          </a:lnRef>
+          <a:fillRef idx="3">
+            <a:schemeClr val="accent1"/>
+          </a:fillRef>
+          <a:effectRef idx="2">
+            <a:schemeClr val="accent1"/>
+          </a:effectRef>
+          <a:fontRef idx="minor">
+            <a:schemeClr val="lt1"/>
+          </a:fontRef>
+        </p:style>
+        <p:txBody>
+          <a:bodyPr rtlCol="0" anchor="ctr"/>
+          <a:lstStyle/>
+          <a:p>
+            <a:pPr algn="ctr"/>
+          </a:p>
+        </p:txBody>
+      </p:sp>
+      <p:sp>
+        <p:nvSpPr>
+          <p:cNvPr id="6" name="TextBox 5"/>
+          <p:cNvSpPr txBox="1"/>
+          <p:nvPr/>
+        </p:nvSpPr>
+        <p:spPr>
+          <a:xfrm>
+            <a:off x="704088" y="1325880"/>
+            <a:ext cx="4224527" cy="4937760"/>
+          </a:xfrm>
+          <a:prstGeom prst="rect">
+            <a:avLst/>
+          </a:prstGeom>
+          <a:noFill/>
+        </p:spPr>
+        <p:txBody>
+          <a:bodyPr wrap="square" lIns="237744" rIns="237744" tIns="237744" bIns="237744">
+            <a:spAutoFit/>
+          </a:bodyPr>
+          <a:lstStyle/>
+          <a:p>
+            <a:pPr>
+              <a:spcAft>
+                <a:spcPts val="180"/>
+              </a:spcAft>
+              <a:defRPr sz="1800" b="0" i="0">
+                <a:solidFill>
+                  <a:srgbClr val="EAE8E2"/>
+                </a:solidFill>
+                <a:latin typeface="Georgia"/>
+              </a:defRPr>
+            </a:pPr>
+            <a:r>
+              <a:t>空间开始有逻辑。</a:t>
+            </a:r>
+          </a:p>
+          <a:p>
+            <a:pPr>
+              <a:spcAft>
+                <a:spcPts val="180"/>
+              </a:spcAft>
+              <a:defRPr sz="1800" b="0" i="0">
+                <a:solidFill>
+                  <a:srgbClr val="EAE8E2"/>
+                </a:solidFill>
+                <a:latin typeface="Georgia"/>
+              </a:defRPr>
+            </a:pPr>
+            <a:r>
+              <a:t>人物开始有重量。</a:t>
+            </a:r>
+          </a:p>
+          <a:p>
+            <a:pPr>
+              <a:spcAft>
+                <a:spcPts val="180"/>
+              </a:spcAft>
+              <a:defRPr sz="1800" b="0" i="0">
+                <a:solidFill>
+                  <a:srgbClr val="EAE8E2"/>
+                </a:solidFill>
+                <a:latin typeface="Georgia"/>
+              </a:defRPr>
+            </a:pPr>
+            <a:r>
+              <a:t>观看开始带有立场。</a:t>
+            </a:r>
+          </a:p>
+        </p:txBody>
+      </p:sp>
+      <p:pic>
+        <p:nvPicPr>
+          <p:cNvPr id="7" name="Picture 6" descr="tmpc9_60ed4.png"/>
+          <p:cNvPicPr>
+            <a:picLocks noChangeAspect="1"/>
+          </p:cNvPicPr>
+          <p:nvPr/>
+        </p:nvPicPr>
+        <p:blipFill>
+          <a:blip r:embed="rId2"/>
+          <a:stretch>
+            <a:fillRect/>
+          </a:stretch>
+        </p:blipFill>
+        <p:spPr>
+          <a:xfrm>
+            <a:off x="5285231" y="1280160"/>
+            <a:ext cx="3200400" cy="5029200"/>
+          </a:xfrm>
+          <a:prstGeom prst="rect">
+            <a:avLst/>
+          </a:prstGeom>
+        </p:spPr>
+      </p:pic>
     </p:spTree>
   </p:cSld>
   <p:clrMapOvr>
@@ -3916,9 +4076,17 @@
   <p:cSld>
     <p:bg>
       <p:bgPr>
-        <a:solidFill>
-          <a:srgbClr val="FFFAF0"/>
-        </a:solidFill>
+        <a:gradFill rotWithShape="1">
+          <a:gsLst>
+            <a:gs pos="0">
+              <a:srgbClr val="19161C"/>
+            </a:gs>
+            <a:gs pos="100000">
+              <a:srgbClr val="362A3A"/>
+            </a:gs>
+          </a:gsLst>
+          <a:lin scaled="0" ang="5400000"/>
+        </a:gradFill>
         <a:effectLst/>
       </p:bgPr>
     </p:bg>
@@ -3929,94 +4097,147 @@
         <p:nvPr/>
       </p:nvGrpSpPr>
       <p:grpSpPr/>
-      <p:sp>
-        <p:nvSpPr>
-          <p:cNvPr id="2" name="Title 1"/>
-          <p:cNvSpPr>
-            <a:spLocks noGrp="1"/>
-          </p:cNvSpPr>
-          <p:nvPr>
-            <p:ph type="title"/>
-          </p:nvPr>
-        </p:nvSpPr>
-        <p:spPr/>
-        <p:txBody>
-          <a:bodyPr/>
-          <a:lstStyle/>
-          <a:p>
-            <a:r>
-              <a:rPr>
-                <a:solidFill>
-                  <a:srgbClr val="C83296"/>
-                </a:solidFill>
-                <a:latin typeface="Verdana"/>
-              </a:rPr>
-              <a:t>晕涂法与大气透视</a:t>
-            </a:r>
-          </a:p>
-        </p:txBody>
-      </p:sp>
-      <p:sp>
-        <p:nvSpPr>
-          <p:cNvPr id="3" name="Content Placeholder 2"/>
-          <p:cNvSpPr>
-            <a:spLocks noGrp="1"/>
-          </p:cNvSpPr>
-          <p:nvPr>
-            <p:ph idx="1"/>
-          </p:nvPr>
-        </p:nvSpPr>
-        <p:spPr/>
-        <p:txBody>
-          <a:bodyPr wrap="square"/>
-          <a:lstStyle/>
-          <a:p/>
-          <a:p>
-            <a:pPr/>
-            <a:r>
-              <a:rPr>
-                <a:solidFill>
-                  <a:srgbClr val="3C283C"/>
-                </a:solidFill>
-                <a:latin typeface="Verdana"/>
-              </a:rPr>
-              <a:t>晕涂法 (Sfumato)：达芬奇通过层层薄釉色消除轮廓线，营造出如烟雾般的柔和过度。</a:t>
-            </a:r>
-          </a:p>
-          <a:p>
-            <a:pPr/>
-            <a:r>
-              <a:rPr>
-                <a:solidFill>
-                  <a:srgbClr val="3C283C"/>
-                </a:solidFill>
-                <a:latin typeface="Verdana"/>
-              </a:rPr>
-              <a:t>《蒙娜丽莎》中的色彩博弈：利用冷暖色调在背景中建立的大气远近感。</a:t>
-            </a:r>
-          </a:p>
-          <a:p>
-            <a:pPr/>
-            <a:r>
-              <a:rPr>
-                <a:solidFill>
-                  <a:srgbClr val="3C283C"/>
-                </a:solidFill>
-                <a:latin typeface="Verdana"/>
-              </a:rPr>
-              <a:t>威尼斯画派：提香与乔尔乔内对“色彩建构模型”的重视，挑战了佛罗伦萨的“素描中心论”。</a:t>
-            </a:r>
-          </a:p>
-          <a:p>
-            <a:pPr/>
-            <a:r>
-              <a:rPr>
-                <a:solidFill>
-                  <a:srgbClr val="3C283C"/>
-                </a:solidFill>
-                <a:latin typeface="Verdana"/>
-              </a:rPr>
-              <a:t>明暗对照法 (Chiaroscuro)：利用极端的光源对比，增强人物的情感张力与体积感。</a:t>
+      <p:pic>
+        <p:nvPicPr>
+          <p:cNvPr id="2" name="Picture 1" descr="tmp3_6ood0s.png"/>
+          <p:cNvPicPr>
+            <a:picLocks noChangeAspect="1"/>
+          </p:cNvPicPr>
+          <p:nvPr/>
+        </p:nvPicPr>
+        <p:blipFill>
+          <a:blip r:embed="rId2"/>
+          <a:stretch>
+            <a:fillRect/>
+          </a:stretch>
+        </p:blipFill>
+        <p:spPr>
+          <a:xfrm>
+            <a:off x="0" y="0"/>
+            <a:ext cx="9144000" cy="6858000"/>
+          </a:xfrm>
+          <a:prstGeom prst="rect">
+            <a:avLst/>
+          </a:prstGeom>
+        </p:spPr>
+      </p:pic>
+      <p:sp>
+        <p:nvSpPr>
+          <p:cNvPr id="3" name="Rectangle 2"/>
+          <p:cNvSpPr/>
+          <p:nvPr/>
+        </p:nvSpPr>
+        <p:spPr>
+          <a:xfrm>
+            <a:off x="0" y="0"/>
+            <a:ext cx="9144000" cy="6858000"/>
+          </a:xfrm>
+          <a:prstGeom prst="rect">
+            <a:avLst/>
+          </a:prstGeom>
+          <a:solidFill>
+            <a:srgbClr val="080C12"/>
+          </a:solidFill>
+          <a:ln>
+            <a:noFill/>
+          </a:ln>
+        </p:spPr>
+        <p:style>
+          <a:lnRef idx="1">
+            <a:schemeClr val="accent1"/>
+          </a:lnRef>
+          <a:fillRef idx="3">
+            <a:schemeClr val="accent1"/>
+          </a:fillRef>
+          <a:effectRef idx="2">
+            <a:schemeClr val="accent1"/>
+          </a:effectRef>
+          <a:fontRef idx="minor">
+            <a:schemeClr val="lt1"/>
+          </a:fontRef>
+        </p:style>
+        <p:txBody>
+          <a:bodyPr rtlCol="0" anchor="ctr"/>
+          <a:lstStyle/>
+          <a:p>
+            <a:pPr algn="ctr"/>
+          </a:p>
+        </p:txBody>
+      </p:sp>
+      <p:sp>
+        <p:nvSpPr>
+          <p:cNvPr id="4" name="TextBox 3"/>
+          <p:cNvSpPr txBox="1"/>
+          <p:nvPr/>
+        </p:nvSpPr>
+        <p:spPr>
+          <a:xfrm>
+            <a:off x="640080" y="4389120"/>
+            <a:ext cx="7863840" cy="1097280"/>
+          </a:xfrm>
+          <a:prstGeom prst="rect">
+            <a:avLst/>
+          </a:prstGeom>
+          <a:noFill/>
+        </p:spPr>
+        <p:txBody>
+          <a:bodyPr wrap="square" lIns="237744" rIns="237744" tIns="237744" bIns="237744">
+            <a:spAutoFit/>
+          </a:bodyPr>
+          <a:lstStyle/>
+          <a:p>
+            <a:pPr>
+              <a:spcAft>
+                <a:spcPts val="552"/>
+              </a:spcAft>
+              <a:defRPr sz="4600" b="1" i="0">
+                <a:solidFill>
+                  <a:srgbClr val="FFFFFF"/>
+                </a:solidFill>
+                <a:latin typeface="Georgia"/>
+              </a:defRPr>
+            </a:pPr>
+            <a:r>
+              <a:t>作品墙式图片页</a:t>
+            </a:r>
+          </a:p>
+        </p:txBody>
+      </p:sp>
+      <p:sp>
+        <p:nvSpPr>
+          <p:cNvPr id="5" name="TextBox 4"/>
+          <p:cNvSpPr txBox="1"/>
+          <p:nvPr/>
+        </p:nvSpPr>
+        <p:spPr>
+          <a:xfrm>
+            <a:off x="640080" y="6144768"/>
+            <a:ext cx="7863840" cy="274320"/>
+          </a:xfrm>
+          <a:prstGeom prst="rect">
+            <a:avLst/>
+          </a:prstGeom>
+          <a:noFill/>
+        </p:spPr>
+        <p:txBody>
+          <a:bodyPr wrap="square" lIns="237744" rIns="237744" tIns="237744" bIns="237744">
+            <a:spAutoFit/>
+          </a:bodyPr>
+          <a:lstStyle/>
+          <a:p>
+            <a:pPr>
+              <a:spcAft>
+                <a:spcPts val="144"/>
+              </a:spcAft>
+              <a:defRPr sz="1200" b="0" i="0">
+                <a:solidFill>
+                  <a:srgbClr val="F4F7FA"/>
+                </a:solidFill>
+                <a:latin typeface="Georgia"/>
+              </a:defRPr>
+            </a:pPr>
+            <a:r>
+              <a:t>用整页图片维持观看节奏，而不是把每页都塞满说明</a:t>
             </a:r>
           </a:p>
         </p:txBody>
@@ -4032,6 +4253,22 @@
 <file path=ppt/slides/slide6.xml><?xml version="1.0" encoding="utf-8"?>
 <p:sld xmlns:a="http://schemas.openxmlformats.org/drawingml/2006/main" xmlns:p="http://schemas.openxmlformats.org/presentationml/2006/main" xmlns:r="http://schemas.openxmlformats.org/officeDocument/2006/relationships">
   <p:cSld>
+    <p:bg>
+      <p:bgPr>
+        <a:gradFill rotWithShape="1">
+          <a:gsLst>
+            <a:gs pos="0">
+              <a:srgbClr val="19161C"/>
+            </a:gs>
+            <a:gs pos="100000">
+              <a:srgbClr val="362A3A"/>
+            </a:gs>
+          </a:gsLst>
+          <a:lin scaled="0" ang="5400000"/>
+        </a:gradFill>
+        <a:effectLst/>
+      </p:bgPr>
+    </p:bg>
     <p:spTree>
       <p:nvGrpSpPr>
         <p:cNvPr id="1" name=""/>
@@ -4041,19 +4278,889 @@
       <p:grpSpPr/>
       <p:sp>
         <p:nvSpPr>
-          <p:cNvPr id="2" name="Title 1"/>
-          <p:cNvSpPr>
-            <a:spLocks noGrp="1"/>
-          </p:cNvSpPr>
-          <p:nvPr>
-            <p:ph type="title"/>
-          </p:nvPr>
-        </p:nvSpPr>
-        <p:spPr/>
-        <p:txBody>
-          <a:bodyPr/>
-          <a:lstStyle/>
-          <a:p>
+          <p:cNvPr id="2" name="TextBox 1"/>
+          <p:cNvSpPr txBox="1"/>
+          <p:nvPr/>
+        </p:nvSpPr>
+        <p:spPr>
+          <a:xfrm>
+            <a:off x="640080" y="411480"/>
+            <a:ext cx="7498079" cy="1645920"/>
+          </a:xfrm>
+          <a:prstGeom prst="rect">
+            <a:avLst/>
+          </a:prstGeom>
+          <a:noFill/>
+        </p:spPr>
+        <p:txBody>
+          <a:bodyPr wrap="square" lIns="237744" rIns="237744" tIns="237744" bIns="237744">
+            <a:spAutoFit/>
+          </a:bodyPr>
+          <a:lstStyle/>
+          <a:p>
+            <a:pPr>
+              <a:spcAft>
+                <a:spcPts val="140"/>
+              </a:spcAft>
+              <a:defRPr sz="2800" b="1" i="0">
+                <a:solidFill>
+                  <a:srgbClr val="E2BF5A"/>
+                </a:solidFill>
+                <a:latin typeface="Georgia"/>
+              </a:defRPr>
+            </a:pPr>
+            <a:r>
+              <a:t>早期 vs 盛期文艺复兴</a:t>
+            </a:r>
+          </a:p>
+        </p:txBody>
+      </p:sp>
+      <p:sp>
+        <p:nvSpPr>
+          <p:cNvPr id="3" name="Rectangle 2"/>
+          <p:cNvSpPr/>
+          <p:nvPr/>
+        </p:nvSpPr>
+        <p:spPr>
+          <a:xfrm>
+            <a:off x="640080" y="1197863"/>
+            <a:ext cx="1371600" cy="45720"/>
+          </a:xfrm>
+          <a:prstGeom prst="rect">
+            <a:avLst/>
+          </a:prstGeom>
+          <a:solidFill>
+            <a:srgbClr val="CC9C48"/>
+          </a:solidFill>
+          <a:ln>
+            <a:noFill/>
+          </a:ln>
+        </p:spPr>
+        <p:style>
+          <a:lnRef idx="1">
+            <a:schemeClr val="accent1"/>
+          </a:lnRef>
+          <a:fillRef idx="3">
+            <a:schemeClr val="accent1"/>
+          </a:fillRef>
+          <a:effectRef idx="2">
+            <a:schemeClr val="accent1"/>
+          </a:effectRef>
+          <a:fontRef idx="minor">
+            <a:schemeClr val="lt1"/>
+          </a:fontRef>
+        </p:style>
+        <p:txBody>
+          <a:bodyPr rtlCol="0" anchor="ctr"/>
+          <a:lstStyle/>
+          <a:p>
+            <a:pPr algn="ctr"/>
+          </a:p>
+        </p:txBody>
+      </p:sp>
+      <p:sp>
+        <p:nvSpPr>
+          <p:cNvPr id="4" name="Rounded Rectangle 3"/>
+          <p:cNvSpPr/>
+          <p:nvPr/>
+        </p:nvSpPr>
+        <p:spPr>
+          <a:xfrm>
+            <a:off x="658368" y="1280160"/>
+            <a:ext cx="3758183" cy="5029200"/>
+          </a:xfrm>
+          <a:prstGeom prst="roundRect">
+            <a:avLst/>
+          </a:prstGeom>
+          <a:solidFill>
+            <a:srgbClr val="262028"/>
+          </a:solidFill>
+          <a:ln w="15875">
+            <a:solidFill>
+              <a:srgbClr val="6F5A37"/>
+            </a:solidFill>
+          </a:ln>
+        </p:spPr>
+        <p:style>
+          <a:lnRef idx="1">
+            <a:schemeClr val="accent1"/>
+          </a:lnRef>
+          <a:fillRef idx="3">
+            <a:schemeClr val="accent1"/>
+          </a:fillRef>
+          <a:effectRef idx="2">
+            <a:schemeClr val="accent1"/>
+          </a:effectRef>
+          <a:fontRef idx="minor">
+            <a:schemeClr val="lt1"/>
+          </a:fontRef>
+        </p:style>
+        <p:txBody>
+          <a:bodyPr rtlCol="0" anchor="ctr"/>
+          <a:lstStyle/>
+          <a:p>
+            <a:pPr algn="ctr"/>
+          </a:p>
+        </p:txBody>
+      </p:sp>
+      <p:sp>
+        <p:nvSpPr>
+          <p:cNvPr id="5" name="Rounded Rectangle 4"/>
+          <p:cNvSpPr/>
+          <p:nvPr/>
+        </p:nvSpPr>
+        <p:spPr>
+          <a:xfrm>
+            <a:off x="4727447" y="1280160"/>
+            <a:ext cx="3758183" cy="5029200"/>
+          </a:xfrm>
+          <a:prstGeom prst="roundRect">
+            <a:avLst/>
+          </a:prstGeom>
+          <a:solidFill>
+            <a:srgbClr val="262028"/>
+          </a:solidFill>
+          <a:ln w="15875">
+            <a:solidFill>
+              <a:srgbClr val="6F5A37"/>
+            </a:solidFill>
+          </a:ln>
+        </p:spPr>
+        <p:style>
+          <a:lnRef idx="1">
+            <a:schemeClr val="accent1"/>
+          </a:lnRef>
+          <a:fillRef idx="3">
+            <a:schemeClr val="accent1"/>
+          </a:fillRef>
+          <a:effectRef idx="2">
+            <a:schemeClr val="accent1"/>
+          </a:effectRef>
+          <a:fontRef idx="minor">
+            <a:schemeClr val="lt1"/>
+          </a:fontRef>
+        </p:style>
+        <p:txBody>
+          <a:bodyPr rtlCol="0" anchor="ctr"/>
+          <a:lstStyle/>
+          <a:p>
+            <a:pPr algn="ctr"/>
+          </a:p>
+        </p:txBody>
+      </p:sp>
+      <p:sp>
+        <p:nvSpPr>
+          <p:cNvPr id="6" name="TextBox 5"/>
+          <p:cNvSpPr txBox="1"/>
+          <p:nvPr/>
+        </p:nvSpPr>
+        <p:spPr>
+          <a:xfrm>
+            <a:off x="731519" y="1353312"/>
+            <a:ext cx="3611879" cy="411480"/>
+          </a:xfrm>
+          <a:prstGeom prst="rect">
+            <a:avLst/>
+          </a:prstGeom>
+          <a:noFill/>
+        </p:spPr>
+        <p:txBody>
+          <a:bodyPr wrap="square" lIns="237744" rIns="237744" tIns="237744" bIns="237744">
+            <a:spAutoFit/>
+          </a:bodyPr>
+          <a:lstStyle/>
+          <a:p>
+            <a:pPr>
+              <a:spcAft>
+                <a:spcPts val="216"/>
+              </a:spcAft>
+              <a:defRPr sz="1800" b="1" i="0">
+                <a:solidFill>
+                  <a:srgbClr val="CC9C48"/>
+                </a:solidFill>
+                <a:latin typeface="Aptos"/>
+              </a:defRPr>
+            </a:pPr>
+            <a:r>
+              <a:t>早期</a:t>
+            </a:r>
+          </a:p>
+        </p:txBody>
+      </p:sp>
+      <p:sp>
+        <p:nvSpPr>
+          <p:cNvPr id="7" name="TextBox 6"/>
+          <p:cNvSpPr txBox="1"/>
+          <p:nvPr/>
+        </p:nvSpPr>
+        <p:spPr>
+          <a:xfrm>
+            <a:off x="4800599" y="1353312"/>
+            <a:ext cx="3611879" cy="411480"/>
+          </a:xfrm>
+          <a:prstGeom prst="rect">
+            <a:avLst/>
+          </a:prstGeom>
+          <a:noFill/>
+        </p:spPr>
+        <p:txBody>
+          <a:bodyPr wrap="square" lIns="237744" rIns="237744" tIns="237744" bIns="237744">
+            <a:spAutoFit/>
+          </a:bodyPr>
+          <a:lstStyle/>
+          <a:p>
+            <a:pPr>
+              <a:spcAft>
+                <a:spcPts val="216"/>
+              </a:spcAft>
+              <a:defRPr sz="1800" b="1" i="0">
+                <a:solidFill>
+                  <a:srgbClr val="CC9C48"/>
+                </a:solidFill>
+                <a:latin typeface="Aptos"/>
+              </a:defRPr>
+            </a:pPr>
+            <a:r>
+              <a:t>盛期</a:t>
+            </a:r>
+          </a:p>
+        </p:txBody>
+      </p:sp>
+      <p:sp>
+        <p:nvSpPr>
+          <p:cNvPr id="8" name="TextBox 7"/>
+          <p:cNvSpPr txBox="1"/>
+          <p:nvPr/>
+        </p:nvSpPr>
+        <p:spPr>
+          <a:xfrm>
+            <a:off x="731519" y="1810512"/>
+            <a:ext cx="3611879" cy="4425696"/>
+          </a:xfrm>
+          <a:prstGeom prst="rect">
+            <a:avLst/>
+          </a:prstGeom>
+          <a:noFill/>
+        </p:spPr>
+        <p:txBody>
+          <a:bodyPr wrap="square" lIns="237744" rIns="237744" tIns="237744" bIns="237744">
+            <a:spAutoFit/>
+          </a:bodyPr>
+          <a:lstStyle/>
+          <a:p>
+            <a:pPr>
+              <a:spcAft>
+                <a:spcPts val="180"/>
+              </a:spcAft>
+              <a:defRPr sz="1800" b="0" i="0">
+                <a:solidFill>
+                  <a:srgbClr val="EAE8E2"/>
+                </a:solidFill>
+                <a:latin typeface="Georgia"/>
+              </a:defRPr>
+            </a:pPr>
+            <a:r>
+              <a:t>结构实验</a:t>
+            </a:r>
+          </a:p>
+          <a:p>
+            <a:pPr>
+              <a:spcAft>
+                <a:spcPts val="180"/>
+              </a:spcAft>
+              <a:defRPr sz="1800" b="0" i="0">
+                <a:solidFill>
+                  <a:srgbClr val="EAE8E2"/>
+                </a:solidFill>
+                <a:latin typeface="Georgia"/>
+              </a:defRPr>
+            </a:pPr>
+            <a:r>
+              <a:t>透视成形</a:t>
+            </a:r>
+          </a:p>
+          <a:p>
+            <a:pPr>
+              <a:spcAft>
+                <a:spcPts val="180"/>
+              </a:spcAft>
+              <a:defRPr sz="1800" b="0" i="0">
+                <a:solidFill>
+                  <a:srgbClr val="EAE8E2"/>
+                </a:solidFill>
+                <a:latin typeface="Georgia"/>
+              </a:defRPr>
+            </a:pPr>
+            <a:r>
+              <a:t>情绪克制</a:t>
+            </a:r>
+          </a:p>
+        </p:txBody>
+      </p:sp>
+      <p:sp>
+        <p:nvSpPr>
+          <p:cNvPr id="9" name="TextBox 8"/>
+          <p:cNvSpPr txBox="1"/>
+          <p:nvPr/>
+        </p:nvSpPr>
+        <p:spPr>
+          <a:xfrm>
+            <a:off x="4800599" y="1810512"/>
+            <a:ext cx="3611879" cy="4425696"/>
+          </a:xfrm>
+          <a:prstGeom prst="rect">
+            <a:avLst/>
+          </a:prstGeom>
+          <a:noFill/>
+        </p:spPr>
+        <p:txBody>
+          <a:bodyPr wrap="square" lIns="237744" rIns="237744" tIns="237744" bIns="237744">
+            <a:spAutoFit/>
+          </a:bodyPr>
+          <a:lstStyle/>
+          <a:p>
+            <a:pPr>
+              <a:spcAft>
+                <a:spcPts val="180"/>
+              </a:spcAft>
+              <a:defRPr sz="1800" b="0" i="0">
+                <a:solidFill>
+                  <a:srgbClr val="EAE8E2"/>
+                </a:solidFill>
+                <a:latin typeface="Georgia"/>
+              </a:defRPr>
+            </a:pPr>
+            <a:r>
+              <a:t>构图平衡</a:t>
+            </a:r>
+          </a:p>
+          <a:p>
+            <a:pPr>
+              <a:spcAft>
+                <a:spcPts val="180"/>
+              </a:spcAft>
+              <a:defRPr sz="1800" b="0" i="0">
+                <a:solidFill>
+                  <a:srgbClr val="EAE8E2"/>
+                </a:solidFill>
+                <a:latin typeface="Georgia"/>
+              </a:defRPr>
+            </a:pPr>
+            <a:r>
+              <a:t>身体成熟</a:t>
+            </a:r>
+          </a:p>
+          <a:p>
+            <a:pPr>
+              <a:spcAft>
+                <a:spcPts val="180"/>
+              </a:spcAft>
+              <a:defRPr sz="1800" b="0" i="0">
+                <a:solidFill>
+                  <a:srgbClr val="EAE8E2"/>
+                </a:solidFill>
+                <a:latin typeface="Georgia"/>
+              </a:defRPr>
+            </a:pPr>
+            <a:r>
+              <a:t>理想美成型</a:t>
+            </a:r>
+          </a:p>
+        </p:txBody>
+      </p:sp>
+    </p:spTree>
+  </p:cSld>
+  <p:clrMapOvr>
+    <a:masterClrMapping/>
+  </p:clrMapOvr>
+</p:sld>
+</file>
+
+<file path=ppt/slides/slide7.xml><?xml version="1.0" encoding="utf-8"?>
+<p:sld xmlns:a="http://schemas.openxmlformats.org/drawingml/2006/main" xmlns:p="http://schemas.openxmlformats.org/presentationml/2006/main" xmlns:r="http://schemas.openxmlformats.org/officeDocument/2006/relationships">
+  <p:cSld>
+    <p:bg>
+      <p:bgPr>
+        <a:gradFill rotWithShape="1">
+          <a:gsLst>
+            <a:gs pos="0">
+              <a:srgbClr val="19161C"/>
+            </a:gs>
+            <a:gs pos="100000">
+              <a:srgbClr val="362A3A"/>
+            </a:gs>
+          </a:gsLst>
+          <a:lin scaled="0" ang="5400000"/>
+        </a:gradFill>
+        <a:effectLst/>
+      </p:bgPr>
+    </p:bg>
+    <p:spTree>
+      <p:nvGrpSpPr>
+        <p:cNvPr id="1" name=""/>
+        <p:cNvGrpSpPr/>
+        <p:nvPr/>
+      </p:nvGrpSpPr>
+      <p:grpSpPr/>
+      <p:sp>
+        <p:nvSpPr>
+          <p:cNvPr id="2" name="TextBox 1"/>
+          <p:cNvSpPr txBox="1"/>
+          <p:nvPr/>
+        </p:nvSpPr>
+        <p:spPr>
+          <a:xfrm>
+            <a:off x="640080" y="411480"/>
+            <a:ext cx="7498079" cy="1645920"/>
+          </a:xfrm>
+          <a:prstGeom prst="rect">
+            <a:avLst/>
+          </a:prstGeom>
+          <a:noFill/>
+        </p:spPr>
+        <p:txBody>
+          <a:bodyPr wrap="square" lIns="237744" rIns="237744" tIns="237744" bIns="237744">
+            <a:spAutoFit/>
+          </a:bodyPr>
+          <a:lstStyle/>
+          <a:p>
+            <a:pPr>
+              <a:spcAft>
+                <a:spcPts val="140"/>
+              </a:spcAft>
+              <a:defRPr sz="2800" b="1" i="0">
+                <a:solidFill>
+                  <a:srgbClr val="E2BF5A"/>
+                </a:solidFill>
+                <a:latin typeface="Georgia"/>
+              </a:defRPr>
+            </a:pPr>
+            <a:r>
+              <a:t>如何读一幅作品</a:t>
+            </a:r>
+          </a:p>
+        </p:txBody>
+      </p:sp>
+      <p:sp>
+        <p:nvSpPr>
+          <p:cNvPr id="3" name="Rectangle 2"/>
+          <p:cNvSpPr/>
+          <p:nvPr/>
+        </p:nvSpPr>
+        <p:spPr>
+          <a:xfrm>
+            <a:off x="640080" y="1197863"/>
+            <a:ext cx="1371600" cy="45720"/>
+          </a:xfrm>
+          <a:prstGeom prst="rect">
+            <a:avLst/>
+          </a:prstGeom>
+          <a:solidFill>
+            <a:srgbClr val="CC9C48"/>
+          </a:solidFill>
+          <a:ln>
+            <a:noFill/>
+          </a:ln>
+        </p:spPr>
+        <p:style>
+          <a:lnRef idx="1">
+            <a:schemeClr val="accent1"/>
+          </a:lnRef>
+          <a:fillRef idx="3">
+            <a:schemeClr val="accent1"/>
+          </a:fillRef>
+          <a:effectRef idx="2">
+            <a:schemeClr val="accent1"/>
+          </a:effectRef>
+          <a:fontRef idx="minor">
+            <a:schemeClr val="lt1"/>
+          </a:fontRef>
+        </p:style>
+        <p:txBody>
+          <a:bodyPr rtlCol="0" anchor="ctr"/>
+          <a:lstStyle/>
+          <a:p>
+            <a:pPr algn="ctr"/>
+          </a:p>
+        </p:txBody>
+      </p:sp>
+      <p:sp>
+        <p:nvSpPr>
+          <p:cNvPr id="4" name="Rounded Rectangle 3"/>
+          <p:cNvSpPr/>
+          <p:nvPr/>
+        </p:nvSpPr>
+        <p:spPr>
+          <a:xfrm>
+            <a:off x="658368" y="1280160"/>
+            <a:ext cx="3758183" cy="5029200"/>
+          </a:xfrm>
+          <a:prstGeom prst="roundRect">
+            <a:avLst/>
+          </a:prstGeom>
+          <a:solidFill>
+            <a:srgbClr val="262028"/>
+          </a:solidFill>
+          <a:ln w="15875">
+            <a:solidFill>
+              <a:srgbClr val="6F5A37"/>
+            </a:solidFill>
+          </a:ln>
+        </p:spPr>
+        <p:style>
+          <a:lnRef idx="1">
+            <a:schemeClr val="accent1"/>
+          </a:lnRef>
+          <a:fillRef idx="3">
+            <a:schemeClr val="accent1"/>
+          </a:fillRef>
+          <a:effectRef idx="2">
+            <a:schemeClr val="accent1"/>
+          </a:effectRef>
+          <a:fontRef idx="minor">
+            <a:schemeClr val="lt1"/>
+          </a:fontRef>
+        </p:style>
+        <p:txBody>
+          <a:bodyPr rtlCol="0" anchor="ctr"/>
+          <a:lstStyle/>
+          <a:p>
+            <a:pPr algn="ctr"/>
+          </a:p>
+        </p:txBody>
+      </p:sp>
+      <p:sp>
+        <p:nvSpPr>
+          <p:cNvPr id="5" name="Rounded Rectangle 4"/>
+          <p:cNvSpPr/>
+          <p:nvPr/>
+        </p:nvSpPr>
+        <p:spPr>
+          <a:xfrm>
+            <a:off x="4727447" y="1280160"/>
+            <a:ext cx="3758183" cy="5029200"/>
+          </a:xfrm>
+          <a:prstGeom prst="roundRect">
+            <a:avLst/>
+          </a:prstGeom>
+          <a:solidFill>
+            <a:srgbClr val="262028"/>
+          </a:solidFill>
+          <a:ln w="15875">
+            <a:solidFill>
+              <a:srgbClr val="6F5A37"/>
+            </a:solidFill>
+          </a:ln>
+        </p:spPr>
+        <p:style>
+          <a:lnRef idx="1">
+            <a:schemeClr val="accent1"/>
+          </a:lnRef>
+          <a:fillRef idx="3">
+            <a:schemeClr val="accent1"/>
+          </a:fillRef>
+          <a:effectRef idx="2">
+            <a:schemeClr val="accent1"/>
+          </a:effectRef>
+          <a:fontRef idx="minor">
+            <a:schemeClr val="lt1"/>
+          </a:fontRef>
+        </p:style>
+        <p:txBody>
+          <a:bodyPr rtlCol="0" anchor="ctr"/>
+          <a:lstStyle/>
+          <a:p>
+            <a:pPr algn="ctr"/>
+          </a:p>
+        </p:txBody>
+      </p:sp>
+      <p:sp>
+        <p:nvSpPr>
+          <p:cNvPr id="6" name="TextBox 5"/>
+          <p:cNvSpPr txBox="1"/>
+          <p:nvPr/>
+        </p:nvSpPr>
+        <p:spPr>
+          <a:xfrm>
+            <a:off x="731519" y="1353312"/>
+            <a:ext cx="3611879" cy="411480"/>
+          </a:xfrm>
+          <a:prstGeom prst="rect">
+            <a:avLst/>
+          </a:prstGeom>
+          <a:noFill/>
+        </p:spPr>
+        <p:txBody>
+          <a:bodyPr wrap="square" lIns="237744" rIns="237744" tIns="237744" bIns="237744">
+            <a:spAutoFit/>
+          </a:bodyPr>
+          <a:lstStyle/>
+          <a:p>
+            <a:pPr>
+              <a:spcAft>
+                <a:spcPts val="216"/>
+              </a:spcAft>
+              <a:defRPr sz="1800" b="1" i="0">
+                <a:solidFill>
+                  <a:srgbClr val="CC9C48"/>
+                </a:solidFill>
+                <a:latin typeface="Aptos"/>
+              </a:defRPr>
+            </a:pPr>
+            <a:r>
+              <a:t>形式线索</a:t>
+            </a:r>
+          </a:p>
+        </p:txBody>
+      </p:sp>
+      <p:sp>
+        <p:nvSpPr>
+          <p:cNvPr id="7" name="TextBox 6"/>
+          <p:cNvSpPr txBox="1"/>
+          <p:nvPr/>
+        </p:nvSpPr>
+        <p:spPr>
+          <a:xfrm>
+            <a:off x="4800599" y="1353312"/>
+            <a:ext cx="3611879" cy="411480"/>
+          </a:xfrm>
+          <a:prstGeom prst="rect">
+            <a:avLst/>
+          </a:prstGeom>
+          <a:noFill/>
+        </p:spPr>
+        <p:txBody>
+          <a:bodyPr wrap="square" lIns="237744" rIns="237744" tIns="237744" bIns="237744">
+            <a:spAutoFit/>
+          </a:bodyPr>
+          <a:lstStyle/>
+          <a:p>
+            <a:pPr>
+              <a:spcAft>
+                <a:spcPts val="216"/>
+              </a:spcAft>
+              <a:defRPr sz="1800" b="1" i="0">
+                <a:solidFill>
+                  <a:srgbClr val="CC9C48"/>
+                </a:solidFill>
+                <a:latin typeface="Aptos"/>
+              </a:defRPr>
+            </a:pPr>
+            <a:r>
+              <a:t>文化线索</a:t>
+            </a:r>
+          </a:p>
+        </p:txBody>
+      </p:sp>
+      <p:sp>
+        <p:nvSpPr>
+          <p:cNvPr id="8" name="TextBox 7"/>
+          <p:cNvSpPr txBox="1"/>
+          <p:nvPr/>
+        </p:nvSpPr>
+        <p:spPr>
+          <a:xfrm>
+            <a:off x="731519" y="1810512"/>
+            <a:ext cx="3611879" cy="4425696"/>
+          </a:xfrm>
+          <a:prstGeom prst="rect">
+            <a:avLst/>
+          </a:prstGeom>
+          <a:noFill/>
+        </p:spPr>
+        <p:txBody>
+          <a:bodyPr wrap="square" lIns="237744" rIns="237744" tIns="237744" bIns="237744">
+            <a:spAutoFit/>
+          </a:bodyPr>
+          <a:lstStyle/>
+          <a:p>
+            <a:pPr>
+              <a:spcAft>
+                <a:spcPts val="180"/>
+              </a:spcAft>
+              <a:defRPr sz="1800" b="0" i="0">
+                <a:solidFill>
+                  <a:srgbClr val="EAE8E2"/>
+                </a:solidFill>
+                <a:latin typeface="Georgia"/>
+              </a:defRPr>
+            </a:pPr>
+            <a:r>
+              <a:t>空间组织</a:t>
+            </a:r>
+          </a:p>
+          <a:p>
+            <a:pPr>
+              <a:spcAft>
+                <a:spcPts val="180"/>
+              </a:spcAft>
+              <a:defRPr sz="1800" b="0" i="0">
+                <a:solidFill>
+                  <a:srgbClr val="EAE8E2"/>
+                </a:solidFill>
+                <a:latin typeface="Georgia"/>
+              </a:defRPr>
+            </a:pPr>
+            <a:r>
+              <a:t>光影处理</a:t>
+            </a:r>
+          </a:p>
+          <a:p>
+            <a:pPr>
+              <a:spcAft>
+                <a:spcPts val="180"/>
+              </a:spcAft>
+              <a:defRPr sz="1800" b="0" i="0">
+                <a:solidFill>
+                  <a:srgbClr val="EAE8E2"/>
+                </a:solidFill>
+                <a:latin typeface="Georgia"/>
+              </a:defRPr>
+            </a:pPr>
+            <a:r>
+              <a:t>姿态比例</a:t>
+            </a:r>
+          </a:p>
+        </p:txBody>
+      </p:sp>
+      <p:sp>
+        <p:nvSpPr>
+          <p:cNvPr id="9" name="TextBox 8"/>
+          <p:cNvSpPr txBox="1"/>
+          <p:nvPr/>
+        </p:nvSpPr>
+        <p:spPr>
+          <a:xfrm>
+            <a:off x="4800599" y="1810512"/>
+            <a:ext cx="3611879" cy="4425696"/>
+          </a:xfrm>
+          <a:prstGeom prst="rect">
+            <a:avLst/>
+          </a:prstGeom>
+          <a:noFill/>
+        </p:spPr>
+        <p:txBody>
+          <a:bodyPr wrap="square" lIns="237744" rIns="237744" tIns="237744" bIns="237744">
+            <a:spAutoFit/>
+          </a:bodyPr>
+          <a:lstStyle/>
+          <a:p>
+            <a:pPr>
+              <a:spcAft>
+                <a:spcPts val="180"/>
+              </a:spcAft>
+              <a:defRPr sz="1800" b="0" i="0">
+                <a:solidFill>
+                  <a:srgbClr val="EAE8E2"/>
+                </a:solidFill>
+                <a:latin typeface="Georgia"/>
+              </a:defRPr>
+            </a:pPr>
+            <a:r>
+              <a:t>赞助人</a:t>
+            </a:r>
+          </a:p>
+          <a:p>
+            <a:pPr>
+              <a:spcAft>
+                <a:spcPts val="180"/>
+              </a:spcAft>
+              <a:defRPr sz="1800" b="0" i="0">
+                <a:solidFill>
+                  <a:srgbClr val="EAE8E2"/>
+                </a:solidFill>
+                <a:latin typeface="Georgia"/>
+              </a:defRPr>
+            </a:pPr>
+            <a:r>
+              <a:t>宗教背景</a:t>
+            </a:r>
+          </a:p>
+          <a:p>
+            <a:pPr>
+              <a:spcAft>
+                <a:spcPts val="180"/>
+              </a:spcAft>
+              <a:defRPr sz="1800" b="0" i="0">
+                <a:solidFill>
+                  <a:srgbClr val="EAE8E2"/>
+                </a:solidFill>
+                <a:latin typeface="Georgia"/>
+              </a:defRPr>
+            </a:pPr>
+            <a:r>
+              <a:t>古典引用</a:t>
+            </a:r>
+          </a:p>
+        </p:txBody>
+      </p:sp>
+    </p:spTree>
+  </p:cSld>
+  <p:clrMapOvr>
+    <a:masterClrMapping/>
+  </p:clrMapOvr>
+</p:sld>
+</file>
+
+<file path=ppt/slides/slide8.xml><?xml version="1.0" encoding="utf-8"?>
+<p:sld xmlns:a="http://schemas.openxmlformats.org/drawingml/2006/main" xmlns:p="http://schemas.openxmlformats.org/presentationml/2006/main" xmlns:r="http://schemas.openxmlformats.org/officeDocument/2006/relationships">
+  <p:cSld>
+    <p:bg>
+      <p:bgPr>
+        <a:gradFill rotWithShape="1">
+          <a:gsLst>
+            <a:gs pos="0">
+              <a:srgbClr val="19161C"/>
+            </a:gs>
+            <a:gs pos="100000">
+              <a:srgbClr val="362A3A"/>
+            </a:gs>
+          </a:gsLst>
+          <a:lin scaled="0" ang="5400000"/>
+        </a:gradFill>
+        <a:effectLst/>
+      </p:bgPr>
+    </p:bg>
+    <p:spTree>
+      <p:nvGrpSpPr>
+        <p:cNvPr id="1" name=""/>
+        <p:cNvGrpSpPr/>
+        <p:nvPr/>
+      </p:nvGrpSpPr>
+      <p:grpSpPr/>
+      <p:sp>
+        <p:nvSpPr>
+          <p:cNvPr id="2" name="TextBox 1"/>
+          <p:cNvSpPr txBox="1"/>
+          <p:nvPr/>
+        </p:nvSpPr>
+        <p:spPr>
+          <a:xfrm>
+            <a:off x="640080" y="411480"/>
+            <a:ext cx="7498079" cy="1645920"/>
+          </a:xfrm>
+          <a:prstGeom prst="rect">
+            <a:avLst/>
+          </a:prstGeom>
+          <a:noFill/>
+        </p:spPr>
+        <p:txBody>
+          <a:bodyPr wrap="square" lIns="237744" rIns="237744" tIns="237744" bIns="237744">
+            <a:spAutoFit/>
+          </a:bodyPr>
+          <a:lstStyle/>
+          <a:p>
+            <a:pPr>
+              <a:spcAft>
+                <a:spcPts val="140"/>
+              </a:spcAft>
+              <a:defRPr sz="2800" b="1" i="0">
+                <a:solidFill>
+                  <a:srgbClr val="E2BF5A"/>
+                </a:solidFill>
+                <a:latin typeface="Georgia"/>
+              </a:defRPr>
+            </a:pPr>
             <a:r>
               <a:t>References</a:t>
             </a:r>
@@ -4062,38 +5169,140 @@
       </p:sp>
       <p:sp>
         <p:nvSpPr>
-          <p:cNvPr id="3" name="Content Placeholder 2"/>
-          <p:cNvSpPr>
-            <a:spLocks noGrp="1"/>
-          </p:cNvSpPr>
-          <p:nvPr>
-            <p:ph idx="1"/>
-          </p:nvPr>
-        </p:nvSpPr>
-        <p:spPr/>
-        <p:txBody>
-          <a:bodyPr/>
-          <a:lstStyle/>
-          <a:p/>
+          <p:cNvPr id="3" name="Rectangle 2"/>
+          <p:cNvSpPr/>
+          <p:nvPr/>
+        </p:nvSpPr>
+        <p:spPr>
+          <a:xfrm>
+            <a:off x="640080" y="1197863"/>
+            <a:ext cx="1371600" cy="45720"/>
+          </a:xfrm>
+          <a:prstGeom prst="rect">
+            <a:avLst/>
+          </a:prstGeom>
+          <a:solidFill>
+            <a:srgbClr val="CC9C48"/>
+          </a:solidFill>
+          <a:ln>
+            <a:noFill/>
+          </a:ln>
+        </p:spPr>
+        <p:style>
+          <a:lnRef idx="1">
+            <a:schemeClr val="accent1"/>
+          </a:lnRef>
+          <a:fillRef idx="3">
+            <a:schemeClr val="accent1"/>
+          </a:fillRef>
+          <a:effectRef idx="2">
+            <a:schemeClr val="accent1"/>
+          </a:effectRef>
+          <a:fontRef idx="minor">
+            <a:schemeClr val="lt1"/>
+          </a:fontRef>
+        </p:style>
+        <p:txBody>
+          <a:bodyPr rtlCol="0" anchor="ctr"/>
+          <a:lstStyle/>
+          <a:p>
+            <a:pPr algn="ctr"/>
+          </a:p>
+        </p:txBody>
+      </p:sp>
+      <p:sp>
+        <p:nvSpPr>
+          <p:cNvPr id="4" name="Rounded Rectangle 3"/>
+          <p:cNvSpPr/>
+          <p:nvPr/>
+        </p:nvSpPr>
+        <p:spPr>
+          <a:xfrm>
+            <a:off x="658368" y="1280160"/>
+            <a:ext cx="7827263" cy="5029200"/>
+          </a:xfrm>
+          <a:prstGeom prst="roundRect">
+            <a:avLst/>
+          </a:prstGeom>
+          <a:solidFill>
+            <a:srgbClr val="262028"/>
+          </a:solidFill>
+          <a:ln w="15875">
+            <a:solidFill>
+              <a:srgbClr val="6F5A37"/>
+            </a:solidFill>
+          </a:ln>
+        </p:spPr>
+        <p:style>
+          <a:lnRef idx="1">
+            <a:schemeClr val="accent1"/>
+          </a:lnRef>
+          <a:fillRef idx="3">
+            <a:schemeClr val="accent1"/>
+          </a:fillRef>
+          <a:effectRef idx="2">
+            <a:schemeClr val="accent1"/>
+          </a:effectRef>
+          <a:fontRef idx="minor">
+            <a:schemeClr val="lt1"/>
+          </a:fontRef>
+        </p:style>
+        <p:txBody>
+          <a:bodyPr rtlCol="0" anchor="ctr"/>
+          <a:lstStyle/>
+          <a:p>
+            <a:pPr algn="ctr"/>
+          </a:p>
+        </p:txBody>
+      </p:sp>
+      <p:sp>
+        <p:nvSpPr>
+          <p:cNvPr id="5" name="TextBox 4"/>
+          <p:cNvSpPr txBox="1"/>
+          <p:nvPr/>
+        </p:nvSpPr>
+        <p:spPr>
+          <a:xfrm>
+            <a:off x="731519" y="1353312"/>
+            <a:ext cx="7680959" cy="4882896"/>
+          </a:xfrm>
+          <a:prstGeom prst="rect">
+            <a:avLst/>
+          </a:prstGeom>
+          <a:noFill/>
+        </p:spPr>
+        <p:txBody>
+          <a:bodyPr wrap="square" lIns="237744" rIns="237744" tIns="237744" bIns="237744">
+            <a:spAutoFit/>
+          </a:bodyPr>
+          <a:lstStyle/>
           <a:p>
             <a:pPr>
-              <a:defRPr sz="1200"/>
+              <a:spcAft>
+                <a:spcPts val="44"/>
+              </a:spcAft>
+              <a:defRPr sz="1100" b="0" i="0">
+                <a:solidFill>
+                  <a:srgbClr val="EAE8E2"/>
+                </a:solidFill>
+                <a:latin typeface="Georgia"/>
+              </a:defRPr>
             </a:pPr>
             <a:r>
-              <a:t>https://zh.wikipedia.org/wiki/文艺复兴艺术</a:t>
+              <a:t>https://www.uffizi.it/en/the-uffizi</a:t>
             </a:r>
           </a:p>
           <a:p>
             <a:pPr>
-              <a:defRPr sz="1200"/>
-            </a:pPr>
-            <a:r>
-              <a:t>https://zh.wikipedia.org/wiki/列奥纳多·达·芬奇</a:t>
-            </a:r>
-          </a:p>
-          <a:p>
-            <a:pPr>
-              <a:defRPr sz="1200"/>
+              <a:spcAft>
+                <a:spcPts val="44"/>
+              </a:spcAft>
+              <a:defRPr sz="1100" b="0" i="0">
+                <a:solidFill>
+                  <a:srgbClr val="EAE8E2"/>
+                </a:solidFill>
+                <a:latin typeface="Georgia"/>
+              </a:defRPr>
             </a:pPr>
             <a:r>
               <a:t>https://www.metmuseum.org/toah/hd/itar/hd_itar.htm</a:t>
@@ -4427,324 +5636,4 @@
   </a:objectDefaults>
   <a:extraClrSchemeLst/>
 </a:theme>
-</file>
-
-<file path=ppt/theme/theme2.xml><?xml version="1.0" encoding="utf-8"?>
-<a:theme xmlns:a="http://schemas.openxmlformats.org/drawingml/2006/main" name="Office Theme">
-  <a:themeElements>
-    <a:clrScheme name="Office">
-      <a:dk1>
-        <a:sysClr val="windowText" lastClr="000000"/>
-      </a:dk1>
-      <a:lt1>
-        <a:sysClr val="window" lastClr="FFFFFF"/>
-      </a:lt1>
-      <a:dk2>
-        <a:srgbClr val="1F497D"/>
-      </a:dk2>
-      <a:lt2>
-        <a:srgbClr val="EEECE1"/>
-      </a:lt2>
-      <a:accent1>
-        <a:srgbClr val="4F81BD"/>
-      </a:accent1>
-      <a:accent2>
-        <a:srgbClr val="C0504D"/>
-      </a:accent2>
-      <a:accent3>
-        <a:srgbClr val="9BBB59"/>
-      </a:accent3>
-      <a:accent4>
-        <a:srgbClr val="8064A2"/>
-      </a:accent4>
-      <a:accent5>
-        <a:srgbClr val="4BACC6"/>
-      </a:accent5>
-      <a:accent6>
-        <a:srgbClr val="F79646"/>
-      </a:accent6>
-      <a:hlink>
-        <a:srgbClr val="0000FF"/>
-      </a:hlink>
-      <a:folHlink>
-        <a:srgbClr val="800080"/>
-      </a:folHlink>
-    </a:clrScheme>
-    <a:fontScheme name="Office">
-      <a:majorFont>
-        <a:latin typeface="Calibri"/>
-        <a:ea typeface=""/>
-        <a:cs typeface=""/>
-        <a:font script="Jpan" typeface="ＭＳ Ｐゴシック"/>
-        <a:font script="Hang" typeface="맑은 고딕"/>
-        <a:font script="Hans" typeface="宋体"/>
-        <a:font script="Hant" typeface="新細明體"/>
-        <a:font script="Arab" typeface="Times New Roman"/>
-        <a:font script="Hebr" typeface="Times New Roman"/>
-        <a:font script="Thai" typeface="Angsana New"/>
-        <a:font script="Ethi" typeface="Nyala"/>
-        <a:font script="Beng" typeface="Vrinda"/>
-        <a:font script="Gujr" typeface="Shruti"/>
-        <a:font script="Khmr" typeface="MoolBoran"/>
-        <a:font script="Knda" typeface="Tunga"/>
-        <a:font script="Guru" typeface="Raavi"/>
-        <a:font script="Cans" typeface="Euphemia"/>
-        <a:font script="Cher" typeface="Plantagenet Cherokee"/>
-        <a:font script="Yiii" typeface="Microsoft Yi Baiti"/>
-        <a:font script="Tibt" typeface="Microsoft Himalaya"/>
-        <a:font script="Thaa" typeface="MV Boli"/>
-        <a:font script="Deva" typeface="Mangal"/>
-        <a:font script="Telu" typeface="Gautami"/>
-        <a:font script="Taml" typeface="Latha"/>
-        <a:font script="Syrc" typeface="Estrangelo Edessa"/>
-        <a:font script="Orya" typeface="Kalinga"/>
-        <a:font script="Mlym" typeface="Kartika"/>
-        <a:font script="Laoo" typeface="DokChampa"/>
-        <a:font script="Sinh" typeface="Iskoola Pota"/>
-        <a:font script="Mong" typeface="Mongolian Baiti"/>
-        <a:font script="Viet" typeface="Times New Roman"/>
-        <a:font script="Uigh" typeface="Microsoft Uighur"/>
-        <a:font script="Geor" typeface="Sylfaen"/>
-      </a:majorFont>
-      <a:minorFont>
-        <a:latin typeface="Calibri"/>
-        <a:ea typeface=""/>
-        <a:cs typeface=""/>
-        <a:font script="Jpan" typeface="ＭＳ Ｐゴシック"/>
-        <a:font script="Hang" typeface="맑은 고딕"/>
-        <a:font script="Hans" typeface="宋体"/>
-        <a:font script="Hant" typeface="新細明體"/>
-        <a:font script="Arab" typeface="Arial"/>
-        <a:font script="Hebr" typeface="Arial"/>
-        <a:font script="Thai" typeface="Cordia New"/>
-        <a:font script="Ethi" typeface="Nyala"/>
-        <a:font script="Beng" typeface="Vrinda"/>
-        <a:font script="Gujr" typeface="Shruti"/>
-        <a:font script="Khmr" typeface="DaunPenh"/>
-        <a:font script="Knda" typeface="Tunga"/>
-        <a:font script="Guru" typeface="Raavi"/>
-        <a:font script="Cans" typeface="Euphemia"/>
-        <a:font script="Cher" typeface="Plantagenet Cherokee"/>
-        <a:font script="Yiii" typeface="Microsoft Yi Baiti"/>
-        <a:font script="Tibt" typeface="Microsoft Himalaya"/>
-        <a:font script="Thaa" typeface="MV Boli"/>
-        <a:font script="Deva" typeface="Mangal"/>
-        <a:font script="Telu" typeface="Gautami"/>
-        <a:font script="Taml" typeface="Latha"/>
-        <a:font script="Syrc" typeface="Estrangelo Edessa"/>
-        <a:font script="Orya" typeface="Kalinga"/>
-        <a:font script="Mlym" typeface="Kartika"/>
-        <a:font script="Laoo" typeface="DokChampa"/>
-        <a:font script="Sinh" typeface="Iskoola Pota"/>
-        <a:font script="Mong" typeface="Mongolian Baiti"/>
-        <a:font script="Viet" typeface="Arial"/>
-        <a:font script="Uigh" typeface="Microsoft Uighur"/>
-        <a:font script="Geor" typeface="Sylfaen"/>
-      </a:minorFont>
-    </a:fontScheme>
-    <a:fmtScheme name="Office">
-      <a:fillStyleLst>
-        <a:solidFill>
-          <a:schemeClr val="phClr"/>
-        </a:solidFill>
-        <a:gradFill rotWithShape="1">
-          <a:gsLst>
-            <a:gs pos="0">
-              <a:schemeClr val="phClr">
-                <a:tint val="50000"/>
-                <a:satMod val="300000"/>
-              </a:schemeClr>
-            </a:gs>
-            <a:gs pos="35000">
-              <a:schemeClr val="phClr">
-                <a:tint val="37000"/>
-                <a:satMod val="300000"/>
-              </a:schemeClr>
-            </a:gs>
-            <a:gs pos="100000">
-              <a:schemeClr val="phClr">
-                <a:tint val="15000"/>
-                <a:satMod val="350000"/>
-              </a:schemeClr>
-            </a:gs>
-          </a:gsLst>
-          <a:lin ang="16200000" scaled="1"/>
-        </a:gradFill>
-        <a:gradFill rotWithShape="1">
-          <a:gsLst>
-            <a:gs pos="0">
-              <a:schemeClr val="phClr">
-                <a:tint val="100000"/>
-                <a:shade val="100000"/>
-                <a:satMod val="130000"/>
-              </a:schemeClr>
-            </a:gs>
-            <a:gs pos="100000">
-              <a:schemeClr val="phClr">
-                <a:tint val="50000"/>
-                <a:shade val="100000"/>
-                <a:satMod val="350000"/>
-              </a:schemeClr>
-            </a:gs>
-          </a:gsLst>
-          <a:lin ang="16200000" scaled="0"/>
-        </a:gradFill>
-      </a:fillStyleLst>
-      <a:lnStyleLst>
-        <a:ln w="9525" cap="flat" cmpd="sng" algn="ctr">
-          <a:solidFill>
-            <a:schemeClr val="phClr">
-              <a:shade val="95000"/>
-              <a:satMod val="105000"/>
-            </a:schemeClr>
-          </a:solidFill>
-          <a:prstDash val="solid"/>
-        </a:ln>
-        <a:ln w="25400" cap="flat" cmpd="sng" algn="ctr">
-          <a:solidFill>
-            <a:schemeClr val="phClr"/>
-          </a:solidFill>
-          <a:prstDash val="solid"/>
-        </a:ln>
-        <a:ln w="38100" cap="flat" cmpd="sng" algn="ctr">
-          <a:solidFill>
-            <a:schemeClr val="phClr"/>
-          </a:solidFill>
-          <a:prstDash val="solid"/>
-        </a:ln>
-      </a:lnStyleLst>
-      <a:effectStyleLst>
-        <a:effectStyle>
-          <a:effectLst>
-            <a:outerShdw blurRad="40000" dist="20000" dir="5400000" rotWithShape="0">
-              <a:srgbClr val="000000">
-                <a:alpha val="38000"/>
-              </a:srgbClr>
-            </a:outerShdw>
-          </a:effectLst>
-        </a:effectStyle>
-        <a:effectStyle>
-          <a:effectLst>
-            <a:outerShdw blurRad="40000" dist="23000" dir="5400000" rotWithShape="0">
-              <a:srgbClr val="000000">
-                <a:alpha val="35000"/>
-              </a:srgbClr>
-            </a:outerShdw>
-          </a:effectLst>
-        </a:effectStyle>
-        <a:effectStyle>
-          <a:effectLst>
-            <a:outerShdw blurRad="40000" dist="23000" dir="5400000" rotWithShape="0">
-              <a:srgbClr val="000000">
-                <a:alpha val="35000"/>
-              </a:srgbClr>
-            </a:outerShdw>
-          </a:effectLst>
-          <a:scene3d>
-            <a:camera prst="orthographicFront">
-              <a:rot lat="0" lon="0" rev="0"/>
-            </a:camera>
-            <a:lightRig rig="threePt" dir="t">
-              <a:rot lat="0" lon="0" rev="1200000"/>
-            </a:lightRig>
-          </a:scene3d>
-          <a:sp3d>
-            <a:bevelT w="63500" h="25400"/>
-          </a:sp3d>
-        </a:effectStyle>
-      </a:effectStyleLst>
-      <a:bgFillStyleLst>
-        <a:solidFill>
-          <a:schemeClr val="phClr"/>
-        </a:solidFill>
-        <a:gradFill rotWithShape="1">
-          <a:gsLst>
-            <a:gs pos="0">
-              <a:schemeClr val="phClr">
-                <a:tint val="40000"/>
-                <a:satMod val="350000"/>
-              </a:schemeClr>
-            </a:gs>
-            <a:gs pos="40000">
-              <a:schemeClr val="phClr">
-                <a:tint val="45000"/>
-                <a:shade val="99000"/>
-                <a:satMod val="350000"/>
-              </a:schemeClr>
-            </a:gs>
-            <a:gs pos="100000">
-              <a:schemeClr val="phClr">
-                <a:shade val="20000"/>
-                <a:satMod val="255000"/>
-              </a:schemeClr>
-            </a:gs>
-          </a:gsLst>
-          <a:path path="circle">
-            <a:fillToRect l="50000" t="-80000" r="50000" b="180000"/>
-          </a:path>
-        </a:gradFill>
-        <a:gradFill rotWithShape="1">
-          <a:gsLst>
-            <a:gs pos="0">
-              <a:schemeClr val="phClr">
-                <a:tint val="80000"/>
-                <a:satMod val="300000"/>
-              </a:schemeClr>
-            </a:gs>
-            <a:gs pos="100000">
-              <a:schemeClr val="phClr">
-                <a:shade val="30000"/>
-                <a:satMod val="200000"/>
-              </a:schemeClr>
-            </a:gs>
-          </a:gsLst>
-          <a:path path="circle">
-            <a:fillToRect l="50000" t="50000" r="50000" b="50000"/>
-          </a:path>
-        </a:gradFill>
-      </a:bgFillStyleLst>
-    </a:fmtScheme>
-  </a:themeElements>
-  <a:objectDefaults>
-    <a:spDef>
-      <a:spPr/>
-      <a:bodyPr/>
-      <a:lstStyle/>
-      <a:style>
-        <a:lnRef idx="1">
-          <a:schemeClr val="accent1"/>
-        </a:lnRef>
-        <a:fillRef idx="3">
-          <a:schemeClr val="accent1"/>
-        </a:fillRef>
-        <a:effectRef idx="2">
-          <a:schemeClr val="accent1"/>
-        </a:effectRef>
-        <a:fontRef idx="minor">
-          <a:schemeClr val="lt1"/>
-        </a:fontRef>
-      </a:style>
-    </a:spDef>
-    <a:lnDef>
-      <a:spPr/>
-      <a:bodyPr/>
-      <a:lstStyle/>
-      <a:style>
-        <a:lnRef idx="2">
-          <a:schemeClr val="accent1"/>
-        </a:lnRef>
-        <a:fillRef idx="0">
-          <a:schemeClr val="accent1"/>
-        </a:fillRef>
-        <a:effectRef idx="1">
-          <a:schemeClr val="accent1"/>
-        </a:effectRef>
-        <a:fontRef idx="minor">
-          <a:schemeClr val="tx1"/>
-        </a:fontRef>
-      </a:style>
-    </a:lnDef>
-  </a:objectDefaults>
-  <a:extraClrSchemeLst/>
-</a:theme>
 </file>
</xml_diff>